<commit_message>
Add set images to the DEPORTES deck (11 slides)
New gallery section with the 360° panorama and two more views of the
set; the cover and deliverables slides now use the high-res renders.
Photos are pre-cropped to their slot so none are stretched. Also fixes
the render-total note, caption wording, icon alt text and a date.

Co-Authored-By: Claude Opus 5.5 <noreply@anthropic.com>
Claude-Session: https://claude.ai/code/session_01TeX7oxyRviBA5uv55G4DVp
</commit_message>
<xml_diff>
--- a/set_virtual_deportes.pptx
+++ b/set_virtual_deportes.pptx
@@ -14,9 +14,11 @@
     <p:sldId id="262" r:id="rId8"/>
     <p:sldId id="263" r:id="rId9"/>
     <p:sldId id="264" r:id="rId10"/>
+    <p:sldId id="265" r:id="rId11"/>
+    <p:sldId id="266" r:id="rId12"/>
   </p:sldIdLst>
   <p:notesMasterIdLst>
-    <p:notesMasterId r:id="rId11"/>
+    <p:notesMasterId r:id="rId13"/>
   </p:notesMasterIdLst>
   <p:sldSz cx="12192000" cy="6858000"/>
   <p:notesSz cx="6858000" cy="12192000"/>
@@ -115,29 +117,35 @@
   <p:extLst>
     <p:ext uri="{521415D9-36F7-43E2-AB2F-B90AF26B5E84}">
       <p14:sectionLst xmlns:p14="http://schemas.microsoft.com/office/powerpoint/2010/main">
-        <p14:section name="Resumen" id="{56aee870-64b2-d00f-ad3c-01eb2b44741e}">
+        <p14:section name="Resumen" id="{06e5df5e-4f77-1251-5f4f-a196f905b40e}">
           <p14:sldIdLst>
             <p14:sldId id="256"/>
             <p14:sldId id="257"/>
           </p14:sldIdLst>
         </p14:section>
-        <p14:section name="El proyecto" id="{55947659-3f11-4b71-1e1c-caf451292253}">
+        <p14:section name="El proyecto" id="{e7406e6f-dffd-82e9-534c-e368a43cce2c}">
           <p14:sldIdLst>
             <p14:sldId id="258"/>
             <p14:sldId id="259"/>
             <p14:sldId id="260"/>
           </p14:sldIdLst>
         </p14:section>
-        <p14:section name="Optimización" id="{4aa9b386-1dad-1131-183c-9bb986961e18}">
+        <p14:section name="Optimización" id="{a048b2ff-d67b-5ae6-4a72-565b36447015}">
           <p14:sldIdLst>
             <p14:sldId id="261"/>
             <p14:sldId id="262"/>
           </p14:sldIdLst>
         </p14:section>
-        <p14:section name="Resultados" id="{f8bdf8b0-71be-09a4-8f33-cb8175ddd6b1}">
+        <p14:section name="Galería" id="{e998ca8e-e641-fa75-b4e4-db414671a393}">
           <p14:sldIdLst>
             <p14:sldId id="263"/>
             <p14:sldId id="264"/>
+          </p14:sldIdLst>
+        </p14:section>
+        <p14:section name="Resultados" id="{a64f8f85-98b6-5f05-fd69-2da93fc9b791}">
+          <p14:sldIdLst>
+            <p14:sldId id="265"/>
+            <p14:sldId id="266"/>
           </p14:sldIdLst>
         </p14:section>
       </p14:sectionLst>
@@ -1734,6 +1742,182 @@
 </p:notes>
 </file>
 
+<file path=ppt/notesSlides/notesSlide10.xml><?xml version="1.0" encoding="utf-8"?>
+<p:notes xmlns:a="http://schemas.openxmlformats.org/drawingml/2006/main" xmlns:r="http://schemas.openxmlformats.org/officeDocument/2006/relationships" xmlns:p="http://schemas.openxmlformats.org/presentationml/2006/main">
+  <p:cSld>
+    <p:spTree>
+      <p:nvGrpSpPr>
+        <p:cNvPr id="1" name=""/>
+        <p:cNvGrpSpPr/>
+        <p:nvPr/>
+      </p:nvGrpSpPr>
+      <p:grpSpPr>
+        <a:xfrm>
+          <a:off x="0" y="0"/>
+          <a:ext cx="0" cy="0"/>
+          <a:chOff x="0" y="0"/>
+          <a:chExt cx="0" cy="0"/>
+        </a:xfrm>
+      </p:grpSpPr>
+      <p:sp>
+        <p:nvSpPr>
+          <p:cNvPr id="2" name="Slide Image Placeholder 1"/>
+          <p:cNvSpPr>
+            <a:spLocks noGrp="1" noRot="1" noChangeAspect="1"/>
+          </p:cNvSpPr>
+          <p:nvPr>
+            <p:ph type="sldImg"/>
+          </p:nvPr>
+        </p:nvSpPr>
+        <p:spPr/>
+      </p:sp>
+      <p:sp>
+        <p:nvSpPr>
+          <p:cNvPr id="3" name="Notes Placeholder 2"/>
+          <p:cNvSpPr>
+            <a:spLocks noGrp="1"/>
+          </p:cNvSpPr>
+          <p:nvPr>
+            <p:ph type="body" idx="1"/>
+          </p:nvPr>
+        </p:nvSpPr>
+        <p:spPr/>
+        <p:txBody>
+          <a:bodyPr/>
+          <a:lstStyle/>
+          <a:p>
+            <a:r>
+              <a:rPr lang="en-US" dirty="0"/>
+              <a:t>Qué se entrega: la escena de Blender empaquetada, con un espacio de trabajo listo para recorrerla; seis imágenes finales, cinco en 4K y una panorámica 360°, en formato de edición y PNG; el vídeo de 45 segundos del recorrido aéreo y tres animaciones de cámara más, listas para renderizar; y la documentación: guía de uso, créditos y licencias, e informe de calidad por fase.</a:t>
+            </a:r>
+            <a:endParaRPr lang="en-US" dirty="0"/>
+          </a:p>
+        </p:txBody>
+      </p:sp>
+      <p:sp>
+        <p:nvSpPr>
+          <p:cNvPr id="4" name="Slide Number Placeholder 3"/>
+          <p:cNvSpPr>
+            <a:spLocks noGrp="1"/>
+          </p:cNvSpPr>
+          <p:nvPr>
+            <p:ph type="sldNum" sz="quarter" idx="10"/>
+          </p:nvPr>
+        </p:nvSpPr>
+        <p:spPr/>
+        <p:txBody>
+          <a:bodyPr/>
+          <a:lstStyle/>
+          <a:p>
+            <a:fld id="{F7021451-1387-4CA6-816F-3879F97B5CBC}" type="slidenum">
+              <a:rPr lang="en-US"/>
+              <a:t>10</a:t>
+            </a:fld>
+            <a:endParaRPr lang="en-US"/>
+          </a:p>
+        </p:txBody>
+      </p:sp>
+    </p:spTree>
+    <p:extLst>
+      <p:ext uri="{BB962C8B-B14F-4D97-AF65-F5344CB8AC3E}">
+        <p14:creationId xmlns:p14="http://schemas.microsoft.com/office/powerpoint/2010/main" val="1024086991"/>
+      </p:ext>
+    </p:extLst>
+  </p:cSld>
+  <p:clrMapOvr>
+    <a:masterClrMapping/>
+  </p:clrMapOvr>
+</p:notes>
+</file>
+
+<file path=ppt/notesSlides/notesSlide11.xml><?xml version="1.0" encoding="utf-8"?>
+<p:notes xmlns:a="http://schemas.openxmlformats.org/drawingml/2006/main" xmlns:r="http://schemas.openxmlformats.org/officeDocument/2006/relationships" xmlns:p="http://schemas.openxmlformats.org/presentationml/2006/main">
+  <p:cSld>
+    <p:spTree>
+      <p:nvGrpSpPr>
+        <p:cNvPr id="1" name=""/>
+        <p:cNvGrpSpPr/>
+        <p:nvPr/>
+      </p:nvGrpSpPr>
+      <p:grpSpPr>
+        <a:xfrm>
+          <a:off x="0" y="0"/>
+          <a:ext cx="0" cy="0"/>
+          <a:chOff x="0" y="0"/>
+          <a:chExt cx="0" cy="0"/>
+        </a:xfrm>
+      </p:grpSpPr>
+      <p:sp>
+        <p:nvSpPr>
+          <p:cNvPr id="2" name="Slide Image Placeholder 1"/>
+          <p:cNvSpPr>
+            <a:spLocks noGrp="1" noRot="1" noChangeAspect="1"/>
+          </p:cNvSpPr>
+          <p:nvPr>
+            <p:ph type="sldImg"/>
+          </p:nvPr>
+        </p:nvSpPr>
+        <p:spPr/>
+      </p:sp>
+      <p:sp>
+        <p:nvSpPr>
+          <p:cNvPr id="3" name="Notes Placeholder 2"/>
+          <p:cNvSpPr>
+            <a:spLocks noGrp="1"/>
+          </p:cNvSpPr>
+          <p:nvPr>
+            <p:ph type="body" idx="1"/>
+          </p:nvPr>
+        </p:nvSpPr>
+        <p:spPr/>
+        <p:txBody>
+          <a:bodyPr/>
+          <a:lstStyle/>
+          <a:p>
+            <a:r>
+              <a:rPr lang="en-US" dirty="0"/>
+              <a:t>Dos siguientes pasos. Primero, repetir la prueba final con las imágenes nuevas y con personas que no conozcan el proyecto. Segundo, liberar espacio: los fotogramas sueltos del vídeo ocupan 16 GB y se pueden borrar si basta con el MP4, y quitar la imagen de referencia del archivo ahorra otros 20 a 30 MB.</a:t>
+            </a:r>
+            <a:endParaRPr lang="en-US" dirty="0"/>
+          </a:p>
+        </p:txBody>
+      </p:sp>
+      <p:sp>
+        <p:nvSpPr>
+          <p:cNvPr id="4" name="Slide Number Placeholder 3"/>
+          <p:cNvSpPr>
+            <a:spLocks noGrp="1"/>
+          </p:cNvSpPr>
+          <p:nvPr>
+            <p:ph type="sldNum" sz="quarter" idx="10"/>
+          </p:nvPr>
+        </p:nvSpPr>
+        <p:spPr/>
+        <p:txBody>
+          <a:bodyPr/>
+          <a:lstStyle/>
+          <a:p>
+            <a:fld id="{F7021451-1387-4CA6-816F-3879F97B5CBC}" type="slidenum">
+              <a:rPr lang="en-US"/>
+              <a:t>11</a:t>
+            </a:fld>
+            <a:endParaRPr lang="en-US"/>
+          </a:p>
+        </p:txBody>
+      </p:sp>
+    </p:spTree>
+    <p:extLst>
+      <p:ext uri="{BB962C8B-B14F-4D97-AF65-F5344CB8AC3E}">
+        <p14:creationId xmlns:p14="http://schemas.microsoft.com/office/powerpoint/2010/main" val="1024086991"/>
+      </p:ext>
+    </p:extLst>
+  </p:cSld>
+  <p:clrMapOvr>
+    <a:masterClrMapping/>
+  </p:clrMapOvr>
+</p:notes>
+</file>
+
 <file path=ppt/notesSlides/notesSlide2.xml><?xml version="1.0" encoding="utf-8"?>
 <p:notes xmlns:a="http://schemas.openxmlformats.org/drawingml/2006/main" xmlns:r="http://schemas.openxmlformats.org/officeDocument/2006/relationships" xmlns:p="http://schemas.openxmlformats.org/presentationml/2006/main">
   <p:cSld>
@@ -2308,7 +2492,7 @@
           <a:p>
             <a:r>
               <a:rPr lang="en-US" dirty="0"/>
-              <a:t>Qué se entrega: la escena de Blender empaquetada, con un espacio de trabajo listo para recorrerla; seis imágenes finales, cinco en 4K y una panorámica 360°, en formato de edición y PNG; el vídeo de 45 segundos del recorrido aéreo y tres animaciones de cámara más, listas para renderizar; y la documentación: guía de uso, créditos y licencias, e informe de calidad por fase.</a:t>
+              <a:t>La panorámica 360° es una de las seis imágenes finales y muestra el plató entero de una vez. En el centro, la mesa principal sobre su tarima, bajo el halo con anillos de luz. A la izquierda, la zona de entrevistas con el sofá; a la derecha, el mueble de madera con vitrinas, la pantalla del estadio y la escalera con el mosaico LED.</a:t>
             </a:r>
             <a:endParaRPr lang="en-US" dirty="0"/>
           </a:p>
@@ -2396,7 +2580,7 @@
           <a:p>
             <a:r>
               <a:rPr lang="en-US" dirty="0"/>
-              <a:t>Dos siguientes pasos. Primero, repetir la prueba final con las imágenes nuevas y con personas que no conozcan el proyecto. Segundo, liberar espacio: los fotogramas sueltos del vídeo ocupan 16 GB y se pueden borrar si basta con el MP4, y quitar la imagen de referencia del archivo ahorra otros 20 a 30 MB.</a:t>
+              <a:t>Dos ángulos más del plató. A la izquierda, la zona de entrevistas: el sofá sobre su tarima de mármol, la escalera con barandilla de vidrio y el mosaico LED, con la mesa principal a la derecha. A la derecha, el punto de vista desde la mesa de presentadores, mirando hacia la pantalla del estadio, la escalera y el sofá.</a:t>
             </a:r>
             <a:endParaRPr lang="en-US" dirty="0"/>
           </a:p>
@@ -2771,7 +2955,7 @@
 
 <file path=ppt/slideLayouts/slideLayout4.xml><?xml version="1.0" encoding="utf-8"?>
 <p:sldLayout xmlns:a="http://schemas.openxmlformats.org/drawingml/2006/main" xmlns:r="http://schemas.openxmlformats.org/officeDocument/2006/relationships" xmlns:p="http://schemas.openxmlformats.org/presentationml/2006/main" preserve="1">
-  <p:cSld name="CIERRE">
+  <p:cSld name="OSCURO">
     <p:bg>
       <p:bgPr>
         <a:solidFill>
@@ -3289,7 +3473,7 @@
       </p:pic>
       <p:pic>
         <p:nvPicPr>
-          <p:cNvPr id="3" name="Degradado de lectura" descr="preencoded.png">    </p:cNvPr>
+          <p:cNvPr id="3" name="Degradado de lectura" descr="Degradado oscuro decorativo">    </p:cNvPr>
           <p:cNvPicPr>
             <a:picLocks noChangeAspect="1"/>
           </p:cNvPicPr>
@@ -3458,9 +3642,1277 @@
                 <a:ea typeface="+mn-lt" pitchFamily="34" charset="-122"/>
                 <a:cs typeface="+mn-lt" pitchFamily="34" charset="-120"/>
               </a:rPr>
-              <a:t>Cámara principal (CAM_01), still final en 4K renderizado en Cycles · Octubre de 2026</a:t>
+              <a:t>Cámara principal (CAM_01), still final en 4K renderizado en Cycles · octubre de 2026</a:t>
             </a:r>
             <a:endParaRPr lang="en-US" sz="1100" dirty="0"/>
+          </a:p>
+        </p:txBody>
+      </p:sp>
+    </p:spTree>
+  </p:cSld>
+  <p:clrMapOvr>
+    <a:masterClrMapping/>
+  </p:clrMapOvr>
+</p:sld>
+</file>
+
+<file path=ppt/slides/slide10.xml><?xml version="1.0" encoding="utf-8"?>
+<p:sld xmlns:a="http://schemas.openxmlformats.org/drawingml/2006/main" xmlns:r="http://schemas.openxmlformats.org/officeDocument/2006/relationships" xmlns:p="http://schemas.openxmlformats.org/presentationml/2006/main">
+  <p:cSld name="Slide 10">
+    <p:spTree>
+      <p:nvGrpSpPr>
+        <p:cNvPr id="1" name=""/>
+        <p:cNvGrpSpPr/>
+        <p:nvPr/>
+      </p:nvGrpSpPr>
+      <p:grpSpPr>
+        <a:xfrm>
+          <a:off x="0" y="0"/>
+          <a:ext cx="0" cy="0"/>
+          <a:chOff x="0" y="0"/>
+          <a:chExt cx="0" cy="0"/>
+        </a:xfrm>
+      </p:grpSpPr>
+      <p:sp>
+        <p:nvSpPr>
+          <p:cNvPr id="2" name="Text 0"/>
+          <p:cNvSpPr/>
+          <p:nvPr>
+            <p:ph idx="100" type="title" hasCustomPrompt="1"/>
+          </p:nvPr>
+        </p:nvSpPr>
+        <p:spPr>
+          <a:xfrm>
+            <a:off x="548640" y="411480"/>
+            <a:ext cx="11094415" cy="777240"/>
+          </a:xfrm>
+          <a:prstGeom prst="rect">
+            <a:avLst/>
+          </a:prstGeom>
+          <a:noFill/>
+          <a:ln/>
+        </p:spPr>
+        <p:txBody>
+          <a:bodyPr wrap="square" lIns="0" tIns="0" rIns="0" bIns="0" rtlCol="0" anchor="ctr"/>
+          <a:lstStyle/>
+          <a:p>
+            <a:pPr algn="l" indent="0" marL="0">
+              <a:buNone/>
+            </a:pPr>
+            <a:r>
+              <a:rPr lang="en-US" sz="3600" b="1" dirty="0">
+                <a:solidFill>
+                  <a:schemeClr val="tx1"/>
+                </a:solidFill>
+              </a:rPr>
+              <a:t>Entregables listos para usar</a:t>
+            </a:r>
+            <a:endParaRPr lang="en-US" sz="3600" dirty="0"/>
+          </a:p>
+        </p:txBody>
+      </p:sp>
+      <p:pic>
+        <p:nvPicPr>
+          <p:cNvPr id="3" name="Foto CAM_02" descr="Plano general del plató con la pantalla del estadio, la mesa sobre su tarima y las vitrinas azules">    </p:cNvPr>
+          <p:cNvPicPr>
+            <a:picLocks noChangeAspect="1"/>
+          </p:cNvPicPr>
+          <p:nvPr/>
+        </p:nvPicPr>
+        <p:blipFill>
+          <a:blip r:embed="rId1"/>
+          <a:stretch>
+            <a:fillRect/>
+          </a:stretch>
+        </p:blipFill>
+        <p:spPr>
+          <a:xfrm>
+            <a:off x="548640" y="1463040"/>
+            <a:ext cx="6309360" cy="4069080"/>
+          </a:xfrm>
+          <a:prstGeom prst="rect">
+            <a:avLst/>
+          </a:prstGeom>
+        </p:spPr>
+      </p:pic>
+      <p:sp>
+        <p:nvSpPr>
+          <p:cNvPr id="4" name="Pie CAM_02"/>
+          <p:cNvSpPr txBox="1"/>
+          <p:nvPr/>
+        </p:nvSpPr>
+        <p:spPr>
+          <a:xfrm>
+            <a:off x="548640" y="5623560"/>
+            <a:ext cx="6309360" cy="274320"/>
+          </a:xfrm>
+          <a:prstGeom prst="rect">
+            <a:avLst/>
+          </a:prstGeom>
+          <a:noFill/>
+          <a:ln/>
+        </p:spPr>
+        <p:txBody>
+          <a:bodyPr wrap="square" lIns="0" tIns="0" rIns="0" bIns="0" rtlCol="0" anchor="ctr"/>
+          <a:lstStyle/>
+          <a:p>
+            <a:pPr indent="0" marL="0">
+              <a:buNone/>
+            </a:pPr>
+            <a:r>
+              <a:rPr lang="en-US" sz="1200" dirty="0">
+                <a:solidFill>
+                  <a:schemeClr val="accent4"/>
+                </a:solidFill>
+                <a:latin typeface="+mn-lt" pitchFamily="34" charset="0"/>
+                <a:ea typeface="+mn-lt" pitchFamily="34" charset="-122"/>
+                <a:cs typeface="+mn-lt" pitchFamily="34" charset="-120"/>
+              </a:rPr>
+              <a:t>Plano general (CAM_02).</a:t>
+            </a:r>
+            <a:endParaRPr lang="en-US" sz="1200" dirty="0"/>
+          </a:p>
+        </p:txBody>
+      </p:sp>
+      <p:sp>
+        <p:nvSpPr>
+          <p:cNvPr id="5" name="Círculo FaCube"/>
+          <p:cNvSpPr/>
+          <p:nvPr/>
+        </p:nvSpPr>
+        <p:spPr>
+          <a:xfrm>
+            <a:off x="7223760" y="1508760"/>
+            <a:ext cx="548640" cy="548640"/>
+          </a:xfrm>
+          <a:prstGeom prst="ellipse">
+            <a:avLst/>
+          </a:prstGeom>
+          <a:solidFill>
+            <a:schemeClr val="accent6"/>
+          </a:solidFill>
+          <a:ln/>
+        </p:spPr>
+      </p:sp>
+      <p:pic>
+        <p:nvPicPr>
+          <p:cNvPr id="6" name="Icono FaCube" descr="Icono de cubo 3D">    </p:cNvPr>
+          <p:cNvPicPr>
+            <a:picLocks noChangeAspect="1"/>
+          </p:cNvPicPr>
+          <p:nvPr/>
+        </p:nvPicPr>
+        <p:blipFill>
+          <a:blip r:embed="rId2"/>
+          <a:stretch>
+            <a:fillRect/>
+          </a:stretch>
+        </p:blipFill>
+        <p:spPr>
+          <a:xfrm>
+            <a:off x="7360920" y="1645920"/>
+            <a:ext cx="274320" cy="274320"/>
+          </a:xfrm>
+          <a:prstGeom prst="rect">
+            <a:avLst/>
+          </a:prstGeom>
+        </p:spPr>
+      </p:pic>
+      <p:sp>
+        <p:nvSpPr>
+          <p:cNvPr id="7" name="Título Escena de Blender"/>
+          <p:cNvSpPr txBox="1"/>
+          <p:nvPr/>
+        </p:nvSpPr>
+        <p:spPr>
+          <a:xfrm>
+            <a:off x="8001000" y="1508760"/>
+            <a:ext cx="3642055" cy="384048"/>
+          </a:xfrm>
+          <a:prstGeom prst="rect">
+            <a:avLst/>
+          </a:prstGeom>
+          <a:noFill/>
+          <a:ln/>
+        </p:spPr>
+        <p:txBody>
+          <a:bodyPr wrap="square" lIns="0" tIns="0" rIns="0" bIns="0" rtlCol="0" anchor="ctr"/>
+          <a:lstStyle/>
+          <a:p>
+            <a:pPr indent="0" marL="0">
+              <a:buNone/>
+            </a:pPr>
+            <a:r>
+              <a:rPr lang="en-US" sz="1800" b="1" dirty="0">
+                <a:solidFill>
+                  <a:schemeClr val="tx1"/>
+                </a:solidFill>
+                <a:latin typeface="+mj-lt" pitchFamily="34" charset="0"/>
+                <a:ea typeface="+mj-lt" pitchFamily="34" charset="-122"/>
+                <a:cs typeface="+mj-lt" pitchFamily="34" charset="-120"/>
+              </a:rPr>
+              <a:t>Escena de Blender</a:t>
+            </a:r>
+            <a:endParaRPr lang="en-US" sz="1800" dirty="0"/>
+          </a:p>
+        </p:txBody>
+      </p:sp>
+      <p:sp>
+        <p:nvSpPr>
+          <p:cNvPr id="8" name="Texto Escena de Blender"/>
+          <p:cNvSpPr txBox="1"/>
+          <p:nvPr/>
+        </p:nvSpPr>
+        <p:spPr>
+          <a:xfrm>
+            <a:off x="8001000" y="1920240"/>
+            <a:ext cx="3642055" cy="571500"/>
+          </a:xfrm>
+          <a:prstGeom prst="rect">
+            <a:avLst/>
+          </a:prstGeom>
+          <a:noFill/>
+          <a:ln/>
+        </p:spPr>
+        <p:txBody>
+          <a:bodyPr wrap="square" lIns="0" tIns="0" rIns="0" bIns="0" rtlCol="0" anchor="t"/>
+          <a:lstStyle/>
+          <a:p>
+            <a:pPr indent="0" marL="0">
+              <a:buNone/>
+            </a:pPr>
+            <a:r>
+              <a:rPr lang="en-US" sz="1500" dirty="0">
+                <a:solidFill>
+                  <a:schemeClr val="tx1"/>
+                </a:solidFill>
+                <a:latin typeface="+mn-lt" pitchFamily="34" charset="0"/>
+                <a:ea typeface="+mn-lt" pitchFamily="34" charset="-122"/>
+                <a:cs typeface="+mn-lt" pitchFamily="34" charset="-120"/>
+              </a:rPr>
+              <a:t>Empaquetada y lista para abrir, con un espacio de trabajo preparado para recorrerla.</a:t>
+            </a:r>
+            <a:endParaRPr lang="en-US" sz="1500" dirty="0"/>
+          </a:p>
+        </p:txBody>
+      </p:sp>
+      <p:sp>
+        <p:nvSpPr>
+          <p:cNvPr id="9" name="Círculo FaImages"/>
+          <p:cNvSpPr/>
+          <p:nvPr/>
+        </p:nvSpPr>
+        <p:spPr>
+          <a:xfrm>
+            <a:off x="7223760" y="2628900"/>
+            <a:ext cx="548640" cy="548640"/>
+          </a:xfrm>
+          <a:prstGeom prst="ellipse">
+            <a:avLst/>
+          </a:prstGeom>
+          <a:solidFill>
+            <a:schemeClr val="accent6"/>
+          </a:solidFill>
+          <a:ln/>
+        </p:spPr>
+      </p:sp>
+      <p:pic>
+        <p:nvPicPr>
+          <p:cNvPr id="10" name="Icono FaImages" descr="Icono de imágenes">    </p:cNvPr>
+          <p:cNvPicPr>
+            <a:picLocks noChangeAspect="1"/>
+          </p:cNvPicPr>
+          <p:nvPr/>
+        </p:nvPicPr>
+        <p:blipFill>
+          <a:blip r:embed="rId3"/>
+          <a:stretch>
+            <a:fillRect/>
+          </a:stretch>
+        </p:blipFill>
+        <p:spPr>
+          <a:xfrm>
+            <a:off x="7360920" y="2766060"/>
+            <a:ext cx="274320" cy="274320"/>
+          </a:xfrm>
+          <a:prstGeom prst="rect">
+            <a:avLst/>
+          </a:prstGeom>
+        </p:spPr>
+      </p:pic>
+      <p:sp>
+        <p:nvSpPr>
+          <p:cNvPr id="11" name="Título Seis imágenes finales"/>
+          <p:cNvSpPr txBox="1"/>
+          <p:nvPr/>
+        </p:nvSpPr>
+        <p:spPr>
+          <a:xfrm>
+            <a:off x="8001000" y="2628900"/>
+            <a:ext cx="3642055" cy="384048"/>
+          </a:xfrm>
+          <a:prstGeom prst="rect">
+            <a:avLst/>
+          </a:prstGeom>
+          <a:noFill/>
+          <a:ln/>
+        </p:spPr>
+        <p:txBody>
+          <a:bodyPr wrap="square" lIns="0" tIns="0" rIns="0" bIns="0" rtlCol="0" anchor="ctr"/>
+          <a:lstStyle/>
+          <a:p>
+            <a:pPr indent="0" marL="0">
+              <a:buNone/>
+            </a:pPr>
+            <a:r>
+              <a:rPr lang="en-US" sz="1800" b="1" dirty="0">
+                <a:solidFill>
+                  <a:schemeClr val="tx1"/>
+                </a:solidFill>
+                <a:latin typeface="+mj-lt" pitchFamily="34" charset="0"/>
+                <a:ea typeface="+mj-lt" pitchFamily="34" charset="-122"/>
+                <a:cs typeface="+mj-lt" pitchFamily="34" charset="-120"/>
+              </a:rPr>
+              <a:t>Seis imágenes finales</a:t>
+            </a:r>
+            <a:endParaRPr lang="en-US" sz="1800" dirty="0"/>
+          </a:p>
+        </p:txBody>
+      </p:sp>
+      <p:sp>
+        <p:nvSpPr>
+          <p:cNvPr id="12" name="Texto Seis imágenes finales"/>
+          <p:cNvSpPr txBox="1"/>
+          <p:nvPr/>
+        </p:nvSpPr>
+        <p:spPr>
+          <a:xfrm>
+            <a:off x="8001000" y="3040380"/>
+            <a:ext cx="3642055" cy="571500"/>
+          </a:xfrm>
+          <a:prstGeom prst="rect">
+            <a:avLst/>
+          </a:prstGeom>
+          <a:noFill/>
+          <a:ln/>
+        </p:spPr>
+        <p:txBody>
+          <a:bodyPr wrap="square" lIns="0" tIns="0" rIns="0" bIns="0" rtlCol="0" anchor="t"/>
+          <a:lstStyle/>
+          <a:p>
+            <a:pPr indent="0" marL="0">
+              <a:buNone/>
+            </a:pPr>
+            <a:r>
+              <a:rPr lang="en-US" sz="1500" dirty="0">
+                <a:solidFill>
+                  <a:schemeClr val="tx1"/>
+                </a:solidFill>
+                <a:latin typeface="+mn-lt" pitchFamily="34" charset="0"/>
+                <a:ea typeface="+mn-lt" pitchFamily="34" charset="-122"/>
+                <a:cs typeface="+mn-lt" pitchFamily="34" charset="-120"/>
+              </a:rPr>
+              <a:t>Cinco en 4K y una panorámica 360°, en formato de edición y en PNG.</a:t>
+            </a:r>
+            <a:endParaRPr lang="en-US" sz="1500" dirty="0"/>
+          </a:p>
+        </p:txBody>
+      </p:sp>
+      <p:sp>
+        <p:nvSpPr>
+          <p:cNvPr id="13" name="Círculo FaFilm"/>
+          <p:cNvSpPr/>
+          <p:nvPr/>
+        </p:nvSpPr>
+        <p:spPr>
+          <a:xfrm>
+            <a:off x="7223760" y="3749040"/>
+            <a:ext cx="548640" cy="548640"/>
+          </a:xfrm>
+          <a:prstGeom prst="ellipse">
+            <a:avLst/>
+          </a:prstGeom>
+          <a:solidFill>
+            <a:schemeClr val="accent6"/>
+          </a:solidFill>
+          <a:ln/>
+        </p:spPr>
+      </p:sp>
+      <p:pic>
+        <p:nvPicPr>
+          <p:cNvPr id="14" name="Icono FaFilm" descr="Icono de película">    </p:cNvPr>
+          <p:cNvPicPr>
+            <a:picLocks noChangeAspect="1"/>
+          </p:cNvPicPr>
+          <p:nvPr/>
+        </p:nvPicPr>
+        <p:blipFill>
+          <a:blip r:embed="rId4"/>
+          <a:stretch>
+            <a:fillRect/>
+          </a:stretch>
+        </p:blipFill>
+        <p:spPr>
+          <a:xfrm>
+            <a:off x="7360920" y="3886200"/>
+            <a:ext cx="274320" cy="274320"/>
+          </a:xfrm>
+          <a:prstGeom prst="rect">
+            <a:avLst/>
+          </a:prstGeom>
+        </p:spPr>
+      </p:pic>
+      <p:sp>
+        <p:nvSpPr>
+          <p:cNvPr id="15" name="Título Vídeo de 45 s"/>
+          <p:cNvSpPr txBox="1"/>
+          <p:nvPr/>
+        </p:nvSpPr>
+        <p:spPr>
+          <a:xfrm>
+            <a:off x="8001000" y="3749040"/>
+            <a:ext cx="3642055" cy="384048"/>
+          </a:xfrm>
+          <a:prstGeom prst="rect">
+            <a:avLst/>
+          </a:prstGeom>
+          <a:noFill/>
+          <a:ln/>
+        </p:spPr>
+        <p:txBody>
+          <a:bodyPr wrap="square" lIns="0" tIns="0" rIns="0" bIns="0" rtlCol="0" anchor="ctr"/>
+          <a:lstStyle/>
+          <a:p>
+            <a:pPr indent="0" marL="0">
+              <a:buNone/>
+            </a:pPr>
+            <a:r>
+              <a:rPr lang="en-US" sz="1800" b="1" dirty="0">
+                <a:solidFill>
+                  <a:schemeClr val="tx1"/>
+                </a:solidFill>
+                <a:latin typeface="+mj-lt" pitchFamily="34" charset="0"/>
+                <a:ea typeface="+mj-lt" pitchFamily="34" charset="-122"/>
+                <a:cs typeface="+mj-lt" pitchFamily="34" charset="-120"/>
+              </a:rPr>
+              <a:t>Vídeo de 45 s</a:t>
+            </a:r>
+            <a:endParaRPr lang="en-US" sz="1800" dirty="0"/>
+          </a:p>
+        </p:txBody>
+      </p:sp>
+      <p:sp>
+        <p:nvSpPr>
+          <p:cNvPr id="16" name="Texto Vídeo de 45 s"/>
+          <p:cNvSpPr txBox="1"/>
+          <p:nvPr/>
+        </p:nvSpPr>
+        <p:spPr>
+          <a:xfrm>
+            <a:off x="8001000" y="4160520"/>
+            <a:ext cx="3642055" cy="571500"/>
+          </a:xfrm>
+          <a:prstGeom prst="rect">
+            <a:avLst/>
+          </a:prstGeom>
+          <a:noFill/>
+          <a:ln/>
+        </p:spPr>
+        <p:txBody>
+          <a:bodyPr wrap="square" lIns="0" tIns="0" rIns="0" bIns="0" rtlCol="0" anchor="t"/>
+          <a:lstStyle/>
+          <a:p>
+            <a:pPr indent="0" marL="0">
+              <a:buNone/>
+            </a:pPr>
+            <a:r>
+              <a:rPr lang="en-US" sz="1500" dirty="0">
+                <a:solidFill>
+                  <a:schemeClr val="tx1"/>
+                </a:solidFill>
+                <a:latin typeface="+mn-lt" pitchFamily="34" charset="0"/>
+                <a:ea typeface="+mn-lt" pitchFamily="34" charset="-122"/>
+                <a:cs typeface="+mn-lt" pitchFamily="34" charset="-120"/>
+              </a:rPr>
+              <a:t>Recorrido aéreo, más tres animaciones de cámara listas para renderizar.</a:t>
+            </a:r>
+            <a:endParaRPr lang="en-US" sz="1500" dirty="0"/>
+          </a:p>
+        </p:txBody>
+      </p:sp>
+      <p:sp>
+        <p:nvSpPr>
+          <p:cNvPr id="17" name="Círculo FaFileLines"/>
+          <p:cNvSpPr/>
+          <p:nvPr/>
+        </p:nvSpPr>
+        <p:spPr>
+          <a:xfrm>
+            <a:off x="7223760" y="4869180"/>
+            <a:ext cx="548640" cy="548640"/>
+          </a:xfrm>
+          <a:prstGeom prst="ellipse">
+            <a:avLst/>
+          </a:prstGeom>
+          <a:solidFill>
+            <a:schemeClr val="accent6"/>
+          </a:solidFill>
+          <a:ln/>
+        </p:spPr>
+      </p:sp>
+      <p:pic>
+        <p:nvPicPr>
+          <p:cNvPr id="18" name="Icono FaFileLines" descr="Icono de documento">    </p:cNvPr>
+          <p:cNvPicPr>
+            <a:picLocks noChangeAspect="1"/>
+          </p:cNvPicPr>
+          <p:nvPr/>
+        </p:nvPicPr>
+        <p:blipFill>
+          <a:blip r:embed="rId5"/>
+          <a:stretch>
+            <a:fillRect/>
+          </a:stretch>
+        </p:blipFill>
+        <p:spPr>
+          <a:xfrm>
+            <a:off x="7360920" y="5006340"/>
+            <a:ext cx="274320" cy="274320"/>
+          </a:xfrm>
+          <a:prstGeom prst="rect">
+            <a:avLst/>
+          </a:prstGeom>
+        </p:spPr>
+      </p:pic>
+      <p:sp>
+        <p:nvSpPr>
+          <p:cNvPr id="19" name="Título Documentación"/>
+          <p:cNvSpPr txBox="1"/>
+          <p:nvPr/>
+        </p:nvSpPr>
+        <p:spPr>
+          <a:xfrm>
+            <a:off x="8001000" y="4869180"/>
+            <a:ext cx="3642055" cy="384048"/>
+          </a:xfrm>
+          <a:prstGeom prst="rect">
+            <a:avLst/>
+          </a:prstGeom>
+          <a:noFill/>
+          <a:ln/>
+        </p:spPr>
+        <p:txBody>
+          <a:bodyPr wrap="square" lIns="0" tIns="0" rIns="0" bIns="0" rtlCol="0" anchor="ctr"/>
+          <a:lstStyle/>
+          <a:p>
+            <a:pPr indent="0" marL="0">
+              <a:buNone/>
+            </a:pPr>
+            <a:r>
+              <a:rPr lang="en-US" sz="1800" b="1" dirty="0">
+                <a:solidFill>
+                  <a:schemeClr val="tx1"/>
+                </a:solidFill>
+                <a:latin typeface="+mj-lt" pitchFamily="34" charset="0"/>
+                <a:ea typeface="+mj-lt" pitchFamily="34" charset="-122"/>
+                <a:cs typeface="+mj-lt" pitchFamily="34" charset="-120"/>
+              </a:rPr>
+              <a:t>Documentación</a:t>
+            </a:r>
+            <a:endParaRPr lang="en-US" sz="1800" dirty="0"/>
+          </a:p>
+        </p:txBody>
+      </p:sp>
+      <p:sp>
+        <p:nvSpPr>
+          <p:cNvPr id="20" name="Texto Documentación"/>
+          <p:cNvSpPr txBox="1"/>
+          <p:nvPr/>
+        </p:nvSpPr>
+        <p:spPr>
+          <a:xfrm>
+            <a:off x="8001000" y="5280660"/>
+            <a:ext cx="3642055" cy="571500"/>
+          </a:xfrm>
+          <a:prstGeom prst="rect">
+            <a:avLst/>
+          </a:prstGeom>
+          <a:noFill/>
+          <a:ln/>
+        </p:spPr>
+        <p:txBody>
+          <a:bodyPr wrap="square" lIns="0" tIns="0" rIns="0" bIns="0" rtlCol="0" anchor="t"/>
+          <a:lstStyle/>
+          <a:p>
+            <a:pPr indent="0" marL="0">
+              <a:buNone/>
+            </a:pPr>
+            <a:r>
+              <a:rPr lang="en-US" sz="1500" dirty="0">
+                <a:solidFill>
+                  <a:schemeClr val="tx1"/>
+                </a:solidFill>
+                <a:latin typeface="+mn-lt" pitchFamily="34" charset="0"/>
+                <a:ea typeface="+mn-lt" pitchFamily="34" charset="-122"/>
+                <a:cs typeface="+mn-lt" pitchFamily="34" charset="-120"/>
+              </a:rPr>
+              <a:t>Guía de uso, créditos y licencias, e informe de calidad fase por fase.</a:t>
+            </a:r>
+            <a:endParaRPr lang="en-US" sz="1500" dirty="0"/>
+          </a:p>
+        </p:txBody>
+      </p:sp>
+      <p:sp>
+        <p:nvSpPr>
+          <p:cNvPr id="25" name="Slide Number Placeholder 0"/>
+          <p:cNvSpPr>
+            <a:spLocks noGrp="1"/>
+          </p:cNvSpPr>
+          <p:nvPr>
+            <p:ph type="sldNum" sz="quarter" idx="4294967295"/>
+          </p:nvPr>
+        </p:nvSpPr>
+        <p:spPr>
+          <a:xfrm>
+            <a:off x="11094415" y="6355080"/>
+            <a:ext cx="548640" cy="274320"/>
+          </a:xfrm>
+          <a:prstGeom prst="rect">
+            <a:avLst/>
+          </a:prstGeom>
+          <a:extLst>
+            <a:ext uri="{C572A759-6A51-4108-AA02-DFA0A04FC94B}">
+              <ma14:wrappingTextBoxFlag xmlns:ma14="http://schemas.microsoft.com/office/mac/drawingml/2011/main" val="0"/>
+            </a:ext>
+          </a:extLst>
+        </p:spPr>
+        <p:txBody>
+          <a:bodyPr lIns="0" tIns="0" rIns="0" bIns="0" anchor="ctr"/>
+          <a:lstStyle>
+            <a:lvl1pPr>
+              <a:defRPr sz="1000">
+                <a:solidFill>
+                  <a:schemeClr val="accent4"/>
+                </a:solidFill>
+              </a:defRPr>
+            </a:lvl1pPr>
+          </a:lstStyle>
+          <a:p>
+            <a:pPr algn="r"/>
+            <a:fld id="{F7021451-1387-4CA6-816F-3879F97B5CBC}" type="slidenum">
+              <a:rPr b="0" lang="en-US"/>
+              <a:t>10</a:t>
+            </a:fld>
+            <a:endParaRPr lang="en-US"/>
+          </a:p>
+        </p:txBody>
+      </p:sp>
+    </p:spTree>
+  </p:cSld>
+  <p:clrMapOvr>
+    <a:masterClrMapping/>
+  </p:clrMapOvr>
+</p:sld>
+</file>
+
+<file path=ppt/slides/slide11.xml><?xml version="1.0" encoding="utf-8"?>
+<p:sld xmlns:a="http://schemas.openxmlformats.org/drawingml/2006/main" xmlns:r="http://schemas.openxmlformats.org/officeDocument/2006/relationships" xmlns:p="http://schemas.openxmlformats.org/presentationml/2006/main">
+  <p:cSld name="Slide 11">
+    <p:spTree>
+      <p:nvGrpSpPr>
+        <p:cNvPr id="1" name=""/>
+        <p:cNvGrpSpPr/>
+        <p:nvPr/>
+      </p:nvGrpSpPr>
+      <p:grpSpPr>
+        <a:xfrm>
+          <a:off x="0" y="0"/>
+          <a:ext cx="0" cy="0"/>
+          <a:chOff x="0" y="0"/>
+          <a:chExt cx="0" cy="0"/>
+        </a:xfrm>
+      </p:grpSpPr>
+      <p:sp>
+        <p:nvSpPr>
+          <p:cNvPr id="2" name="Text 0"/>
+          <p:cNvSpPr/>
+          <p:nvPr>
+            <p:ph idx="100" type="title" hasCustomPrompt="1"/>
+          </p:nvPr>
+        </p:nvSpPr>
+        <p:spPr>
+          <a:xfrm>
+            <a:off x="548640" y="411480"/>
+            <a:ext cx="11094415" cy="777240"/>
+          </a:xfrm>
+          <a:prstGeom prst="rect">
+            <a:avLst/>
+          </a:prstGeom>
+          <a:noFill/>
+          <a:ln/>
+        </p:spPr>
+        <p:txBody>
+          <a:bodyPr wrap="square" lIns="0" tIns="0" rIns="0" bIns="0" rtlCol="0" anchor="ctr"/>
+          <a:lstStyle/>
+          <a:p>
+            <a:pPr algn="l" indent="0" marL="0">
+              <a:buNone/>
+            </a:pPr>
+            <a:r>
+              <a:rPr lang="en-US" sz="3600" b="1" dirty="0">
+                <a:solidFill>
+                  <a:schemeClr val="bg1"/>
+                </a:solidFill>
+              </a:rPr>
+              <a:t>Siguientes pasos</a:t>
+            </a:r>
+            <a:endParaRPr lang="en-US" sz="3600" dirty="0"/>
+          </a:p>
+        </p:txBody>
+      </p:sp>
+      <p:sp>
+        <p:nvSpPr>
+          <p:cNvPr id="3" name="Tarjeta prueba final"/>
+          <p:cNvSpPr/>
+          <p:nvPr/>
+        </p:nvSpPr>
+        <p:spPr>
+          <a:xfrm>
+            <a:off x="548640" y="1554480"/>
+            <a:ext cx="5410048" cy="3749040"/>
+          </a:xfrm>
+          <a:prstGeom prst="roundRect">
+            <a:avLst>
+              <a:gd name="adj" fmla="val 1951"/>
+            </a:avLst>
+          </a:prstGeom>
+          <a:solidFill>
+            <a:schemeClr val="bg1">
+              <a:alpha val="8000"/>
+            </a:schemeClr>
+          </a:solidFill>
+          <a:ln w="9525">
+            <a:solidFill>
+              <a:schemeClr val="bg1">
+                <a:alpha val="20000"/>
+              </a:schemeClr>
+            </a:solidFill>
+            <a:prstDash val="solid"/>
+          </a:ln>
+        </p:spPr>
+      </p:sp>
+      <p:sp>
+        <p:nvSpPr>
+          <p:cNvPr id="4" name="Círculo FaUserCheck"/>
+          <p:cNvSpPr/>
+          <p:nvPr/>
+        </p:nvSpPr>
+        <p:spPr>
+          <a:xfrm>
+            <a:off x="914400" y="1920240"/>
+            <a:ext cx="603504" cy="603504"/>
+          </a:xfrm>
+          <a:prstGeom prst="ellipse">
+            <a:avLst/>
+          </a:prstGeom>
+          <a:solidFill>
+            <a:schemeClr val="accent1"/>
+          </a:solidFill>
+          <a:ln/>
+        </p:spPr>
+      </p:sp>
+      <p:pic>
+        <p:nvPicPr>
+          <p:cNvPr id="5" name="Icono FaUserCheck" descr="Icono de persona con verificación">    </p:cNvPr>
+          <p:cNvPicPr>
+            <a:picLocks noChangeAspect="1"/>
+          </p:cNvPicPr>
+          <p:nvPr/>
+        </p:nvPicPr>
+        <p:blipFill>
+          <a:blip r:embed="rId1"/>
+          <a:stretch>
+            <a:fillRect/>
+          </a:stretch>
+        </p:blipFill>
+        <p:spPr>
+          <a:xfrm>
+            <a:off x="1065276" y="2071116"/>
+            <a:ext cx="301752" cy="301752"/>
+          </a:xfrm>
+          <a:prstGeom prst="rect">
+            <a:avLst/>
+          </a:prstGeom>
+        </p:spPr>
+      </p:pic>
+      <p:sp>
+        <p:nvSpPr>
+          <p:cNvPr id="6" name="Título paso 1"/>
+          <p:cNvSpPr txBox="1"/>
+          <p:nvPr/>
+        </p:nvSpPr>
+        <p:spPr>
+          <a:xfrm>
+            <a:off x="1737360" y="1920240"/>
+            <a:ext cx="3855568" cy="603504"/>
+          </a:xfrm>
+          <a:prstGeom prst="rect">
+            <a:avLst/>
+          </a:prstGeom>
+          <a:noFill/>
+          <a:ln/>
+        </p:spPr>
+        <p:txBody>
+          <a:bodyPr wrap="square" lIns="0" tIns="0" rIns="0" bIns="0" rtlCol="0" anchor="ctr"/>
+          <a:lstStyle/>
+          <a:p>
+            <a:pPr indent="0" marL="0">
+              <a:buNone/>
+            </a:pPr>
+            <a:r>
+              <a:rPr lang="en-US" sz="2400" b="1" dirty="0">
+                <a:solidFill>
+                  <a:schemeClr val="bg1"/>
+                </a:solidFill>
+                <a:latin typeface="+mj-lt" pitchFamily="34" charset="0"/>
+                <a:ea typeface="+mj-lt" pitchFamily="34" charset="-122"/>
+                <a:cs typeface="+mj-lt" pitchFamily="34" charset="-120"/>
+              </a:rPr>
+              <a:t>Repetir la prueba final</a:t>
+            </a:r>
+            <a:endParaRPr lang="en-US" sz="2400" dirty="0"/>
+          </a:p>
+        </p:txBody>
+      </p:sp>
+      <p:sp>
+        <p:nvSpPr>
+          <p:cNvPr id="7" name="Texto paso 1"/>
+          <p:cNvSpPr txBox="1"/>
+          <p:nvPr/>
+        </p:nvSpPr>
+        <p:spPr>
+          <a:xfrm>
+            <a:off x="914400" y="2788920"/>
+            <a:ext cx="4678528" cy="1005840"/>
+          </a:xfrm>
+          <a:prstGeom prst="rect">
+            <a:avLst/>
+          </a:prstGeom>
+          <a:noFill/>
+          <a:ln/>
+        </p:spPr>
+        <p:txBody>
+          <a:bodyPr wrap="square" lIns="0" tIns="0" rIns="0" bIns="0" rtlCol="0" anchor="t"/>
+          <a:lstStyle/>
+          <a:p>
+            <a:pPr indent="0" marL="0">
+              <a:buNone/>
+            </a:pPr>
+            <a:r>
+              <a:rPr lang="en-US" sz="1800" dirty="0">
+                <a:solidFill>
+                  <a:schemeClr val="bg2"/>
+                </a:solidFill>
+                <a:latin typeface="+mn-lt" pitchFamily="34" charset="0"/>
+                <a:ea typeface="+mn-lt" pitchFamily="34" charset="-122"/>
+                <a:cs typeface="+mn-lt" pitchFamily="34" charset="-120"/>
+              </a:rPr>
+              <a:t>Con las imágenes nuevas y con personas que no conozcan el proyecto. La respuesta que se busca:</a:t>
+            </a:r>
+            <a:endParaRPr lang="en-US" sz="1800" dirty="0"/>
+          </a:p>
+        </p:txBody>
+      </p:sp>
+      <p:sp>
+        <p:nvSpPr>
+          <p:cNvPr id="8" name="Cita objetivo"/>
+          <p:cNvSpPr txBox="1"/>
+          <p:nvPr/>
+        </p:nvSpPr>
+        <p:spPr>
+          <a:xfrm>
+            <a:off x="914400" y="3703320"/>
+            <a:ext cx="4678528" cy="822960"/>
+          </a:xfrm>
+          <a:prstGeom prst="rect">
+            <a:avLst/>
+          </a:prstGeom>
+          <a:noFill/>
+          <a:ln/>
+        </p:spPr>
+        <p:txBody>
+          <a:bodyPr wrap="square" lIns="0" tIns="0" rIns="0" bIns="0" rtlCol="0" anchor="ctr"/>
+          <a:lstStyle/>
+          <a:p>
+            <a:pPr indent="0" marL="0">
+              <a:buNone/>
+            </a:pPr>
+            <a:r>
+              <a:rPr lang="en-US" sz="4000" b="1" i="1" dirty="0">
+                <a:solidFill>
+                  <a:schemeClr val="accent3"/>
+                </a:solidFill>
+                <a:latin typeface="+mj-lt" pitchFamily="34" charset="0"/>
+                <a:ea typeface="+mj-lt" pitchFamily="34" charset="-122"/>
+                <a:cs typeface="+mj-lt" pitchFamily="34" charset="-120"/>
+              </a:rPr>
+              <a:t>«Es una foto»</a:t>
+            </a:r>
+            <a:endParaRPr lang="en-US" sz="4000" dirty="0"/>
+          </a:p>
+        </p:txBody>
+      </p:sp>
+      <p:sp>
+        <p:nvSpPr>
+          <p:cNvPr id="9" name="Tarjeta ahorro de espacio"/>
+          <p:cNvSpPr/>
+          <p:nvPr/>
+        </p:nvSpPr>
+        <p:spPr>
+          <a:xfrm>
+            <a:off x="6233008" y="1554480"/>
+            <a:ext cx="5410048" cy="3749040"/>
+          </a:xfrm>
+          <a:prstGeom prst="roundRect">
+            <a:avLst>
+              <a:gd name="adj" fmla="val 1951"/>
+            </a:avLst>
+          </a:prstGeom>
+          <a:solidFill>
+            <a:schemeClr val="bg1">
+              <a:alpha val="8000"/>
+            </a:schemeClr>
+          </a:solidFill>
+          <a:ln w="9525">
+            <a:solidFill>
+              <a:schemeClr val="bg1">
+                <a:alpha val="20000"/>
+              </a:schemeClr>
+            </a:solidFill>
+            <a:prstDash val="solid"/>
+          </a:ln>
+        </p:spPr>
+      </p:sp>
+      <p:sp>
+        <p:nvSpPr>
+          <p:cNvPr id="10" name="Círculo FaHardDrive"/>
+          <p:cNvSpPr/>
+          <p:nvPr/>
+        </p:nvSpPr>
+        <p:spPr>
+          <a:xfrm>
+            <a:off x="6598768" y="1920240"/>
+            <a:ext cx="603504" cy="603504"/>
+          </a:xfrm>
+          <a:prstGeom prst="ellipse">
+            <a:avLst/>
+          </a:prstGeom>
+          <a:solidFill>
+            <a:schemeClr val="accent1"/>
+          </a:solidFill>
+          <a:ln/>
+        </p:spPr>
+      </p:sp>
+      <p:pic>
+        <p:nvPicPr>
+          <p:cNvPr id="11" name="Icono FaHardDrive" descr="Icono de disco duro">    </p:cNvPr>
+          <p:cNvPicPr>
+            <a:picLocks noChangeAspect="1"/>
+          </p:cNvPicPr>
+          <p:nvPr/>
+        </p:nvPicPr>
+        <p:blipFill>
+          <a:blip r:embed="rId2"/>
+          <a:stretch>
+            <a:fillRect/>
+          </a:stretch>
+        </p:blipFill>
+        <p:spPr>
+          <a:xfrm>
+            <a:off x="6749644" y="2071116"/>
+            <a:ext cx="301752" cy="301752"/>
+          </a:xfrm>
+          <a:prstGeom prst="rect">
+            <a:avLst/>
+          </a:prstGeom>
+        </p:spPr>
+      </p:pic>
+      <p:sp>
+        <p:nvSpPr>
+          <p:cNvPr id="12" name="Título paso 2"/>
+          <p:cNvSpPr txBox="1"/>
+          <p:nvPr/>
+        </p:nvSpPr>
+        <p:spPr>
+          <a:xfrm>
+            <a:off x="7421728" y="1920240"/>
+            <a:ext cx="3855568" cy="603504"/>
+          </a:xfrm>
+          <a:prstGeom prst="rect">
+            <a:avLst/>
+          </a:prstGeom>
+          <a:noFill/>
+          <a:ln/>
+        </p:spPr>
+        <p:txBody>
+          <a:bodyPr wrap="square" lIns="0" tIns="0" rIns="0" bIns="0" rtlCol="0" anchor="ctr"/>
+          <a:lstStyle/>
+          <a:p>
+            <a:pPr indent="0" marL="0">
+              <a:buNone/>
+            </a:pPr>
+            <a:r>
+              <a:rPr lang="en-US" sz="2400" b="1" dirty="0">
+                <a:solidFill>
+                  <a:schemeClr val="bg1"/>
+                </a:solidFill>
+                <a:latin typeface="+mj-lt" pitchFamily="34" charset="0"/>
+                <a:ea typeface="+mj-lt" pitchFamily="34" charset="-122"/>
+                <a:cs typeface="+mj-lt" pitchFamily="34" charset="-120"/>
+              </a:rPr>
+              <a:t>Ahorrar espacio</a:t>
+            </a:r>
+            <a:endParaRPr lang="en-US" sz="2400" dirty="0"/>
+          </a:p>
+        </p:txBody>
+      </p:sp>
+      <p:sp>
+        <p:nvSpPr>
+          <p:cNvPr id="13" name="Cifra 16 GB"/>
+          <p:cNvSpPr txBox="1"/>
+          <p:nvPr/>
+        </p:nvSpPr>
+        <p:spPr>
+          <a:xfrm>
+            <a:off x="6598768" y="2788920"/>
+            <a:ext cx="2240280" cy="914400"/>
+          </a:xfrm>
+          <a:prstGeom prst="rect">
+            <a:avLst/>
+          </a:prstGeom>
+          <a:noFill/>
+          <a:ln/>
+        </p:spPr>
+        <p:txBody>
+          <a:bodyPr wrap="square" lIns="0" tIns="0" rIns="0" bIns="0" rtlCol="0" anchor="ctr"/>
+          <a:lstStyle/>
+          <a:p>
+            <a:pPr indent="0" marL="0">
+              <a:buNone/>
+            </a:pPr>
+            <a:r>
+              <a:rPr lang="en-US" sz="3000" b="1" dirty="0">
+                <a:solidFill>
+                  <a:schemeClr val="accent3"/>
+                </a:solidFill>
+                <a:latin typeface="+mj-lt" pitchFamily="34" charset="0"/>
+                <a:ea typeface="+mj-lt" pitchFamily="34" charset="-122"/>
+                <a:cs typeface="+mj-lt" pitchFamily="34" charset="-120"/>
+              </a:rPr>
+              <a:t>16 GB</a:t>
+            </a:r>
+            <a:endParaRPr lang="en-US" sz="3000" dirty="0"/>
+          </a:p>
+        </p:txBody>
+      </p:sp>
+      <p:sp>
+        <p:nvSpPr>
+          <p:cNvPr id="14" name="Texto 16 GB"/>
+          <p:cNvSpPr txBox="1"/>
+          <p:nvPr/>
+        </p:nvSpPr>
+        <p:spPr>
+          <a:xfrm>
+            <a:off x="8930488" y="2788920"/>
+            <a:ext cx="2346808" cy="914400"/>
+          </a:xfrm>
+          <a:prstGeom prst="rect">
+            <a:avLst/>
+          </a:prstGeom>
+          <a:noFill/>
+          <a:ln/>
+        </p:spPr>
+        <p:txBody>
+          <a:bodyPr wrap="square" lIns="0" tIns="0" rIns="0" bIns="0" rtlCol="0" anchor="ctr"/>
+          <a:lstStyle/>
+          <a:p>
+            <a:pPr indent="0" marL="0">
+              <a:buNone/>
+            </a:pPr>
+            <a:r>
+              <a:rPr lang="en-US" sz="1600" dirty="0">
+                <a:solidFill>
+                  <a:schemeClr val="bg2"/>
+                </a:solidFill>
+                <a:latin typeface="+mn-lt" pitchFamily="34" charset="0"/>
+                <a:ea typeface="+mn-lt" pitchFamily="34" charset="-122"/>
+                <a:cs typeface="+mn-lt" pitchFamily="34" charset="-120"/>
+              </a:rPr>
+              <a:t>Fotogramas sueltos del vídeo: se pueden borrar si basta con el MP4.</a:t>
+            </a:r>
+            <a:endParaRPr lang="en-US" sz="1600" dirty="0"/>
+          </a:p>
+        </p:txBody>
+      </p:sp>
+      <p:sp>
+        <p:nvSpPr>
+          <p:cNvPr id="15" name="Cifra 20–30 MB"/>
+          <p:cNvSpPr txBox="1"/>
+          <p:nvPr/>
+        </p:nvSpPr>
+        <p:spPr>
+          <a:xfrm>
+            <a:off x="6598768" y="3931920"/>
+            <a:ext cx="2240280" cy="914400"/>
+          </a:xfrm>
+          <a:prstGeom prst="rect">
+            <a:avLst/>
+          </a:prstGeom>
+          <a:noFill/>
+          <a:ln/>
+        </p:spPr>
+        <p:txBody>
+          <a:bodyPr wrap="square" lIns="0" tIns="0" rIns="0" bIns="0" rtlCol="0" anchor="ctr"/>
+          <a:lstStyle/>
+          <a:p>
+            <a:pPr indent="0" marL="0">
+              <a:buNone/>
+            </a:pPr>
+            <a:r>
+              <a:rPr lang="en-US" sz="3000" b="1" dirty="0">
+                <a:solidFill>
+                  <a:schemeClr val="accent3"/>
+                </a:solidFill>
+                <a:latin typeface="+mj-lt" pitchFamily="34" charset="0"/>
+                <a:ea typeface="+mj-lt" pitchFamily="34" charset="-122"/>
+                <a:cs typeface="+mj-lt" pitchFamily="34" charset="-120"/>
+              </a:rPr>
+              <a:t>20–30 MB</a:t>
+            </a:r>
+            <a:endParaRPr lang="en-US" sz="3000" dirty="0"/>
+          </a:p>
+        </p:txBody>
+      </p:sp>
+      <p:sp>
+        <p:nvSpPr>
+          <p:cNvPr id="16" name="Texto 20–30 MB"/>
+          <p:cNvSpPr txBox="1"/>
+          <p:nvPr/>
+        </p:nvSpPr>
+        <p:spPr>
+          <a:xfrm>
+            <a:off x="8930488" y="3931920"/>
+            <a:ext cx="2346808" cy="914400"/>
+          </a:xfrm>
+          <a:prstGeom prst="rect">
+            <a:avLst/>
+          </a:prstGeom>
+          <a:noFill/>
+          <a:ln/>
+        </p:spPr>
+        <p:txBody>
+          <a:bodyPr wrap="square" lIns="0" tIns="0" rIns="0" bIns="0" rtlCol="0" anchor="ctr"/>
+          <a:lstStyle/>
+          <a:p>
+            <a:pPr indent="0" marL="0">
+              <a:buNone/>
+            </a:pPr>
+            <a:r>
+              <a:rPr lang="en-US" sz="1600" dirty="0">
+                <a:solidFill>
+                  <a:schemeClr val="bg2"/>
+                </a:solidFill>
+                <a:latin typeface="+mn-lt" pitchFamily="34" charset="0"/>
+                <a:ea typeface="+mn-lt" pitchFamily="34" charset="-122"/>
+                <a:cs typeface="+mn-lt" pitchFamily="34" charset="-120"/>
+              </a:rPr>
+              <a:t>Al quitar la imagen de referencia del archivo de Blender.</a:t>
+            </a:r>
+            <a:endParaRPr lang="en-US" sz="1600" dirty="0"/>
+          </a:p>
+        </p:txBody>
+      </p:sp>
+      <p:sp>
+        <p:nvSpPr>
+          <p:cNvPr id="17" name="Ficha técnica"/>
+          <p:cNvSpPr txBox="1"/>
+          <p:nvPr/>
+        </p:nvSpPr>
+        <p:spPr>
+          <a:xfrm>
+            <a:off x="548640" y="5623560"/>
+            <a:ext cx="11094415" cy="320040"/>
+          </a:xfrm>
+          <a:prstGeom prst="rect">
+            <a:avLst/>
+          </a:prstGeom>
+          <a:noFill/>
+          <a:ln/>
+        </p:spPr>
+        <p:txBody>
+          <a:bodyPr wrap="square" lIns="0" tIns="0" rIns="0" bIns="0" rtlCol="0" anchor="t"/>
+          <a:lstStyle/>
+          <a:p>
+            <a:pPr indent="0" marL="0">
+              <a:buNone/>
+            </a:pPr>
+            <a:r>
+              <a:rPr lang="en-US" sz="1400" dirty="0">
+                <a:solidFill>
+                  <a:schemeClr val="accent5"/>
+                </a:solidFill>
+                <a:latin typeface="+mn-lt" pitchFamily="34" charset="0"/>
+                <a:ea typeface="+mn-lt" pitchFamily="34" charset="-122"/>
+                <a:cs typeface="+mn-lt" pitchFamily="34" charset="-120"/>
+              </a:rPr>
+              <a:t>Proyecto set_virtual · octubre de 2026 · Blender 5.2, Cycles y EEVEE en una RTX 5090.</a:t>
+            </a:r>
+            <a:endParaRPr lang="en-US" sz="1400" dirty="0"/>
+          </a:p>
+        </p:txBody>
+      </p:sp>
+      <p:sp>
+        <p:nvSpPr>
+          <p:cNvPr id="25" name="Slide Number Placeholder 0"/>
+          <p:cNvSpPr>
+            <a:spLocks noGrp="1"/>
+          </p:cNvSpPr>
+          <p:nvPr>
+            <p:ph type="sldNum" sz="quarter" idx="4294967295"/>
+          </p:nvPr>
+        </p:nvSpPr>
+        <p:spPr>
+          <a:xfrm>
+            <a:off x="11094415" y="6355080"/>
+            <a:ext cx="548640" cy="274320"/>
+          </a:xfrm>
+          <a:prstGeom prst="rect">
+            <a:avLst/>
+          </a:prstGeom>
+          <a:extLst>
+            <a:ext uri="{C572A759-6A51-4108-AA02-DFA0A04FC94B}">
+              <ma14:wrappingTextBoxFlag xmlns:ma14="http://schemas.microsoft.com/office/mac/drawingml/2011/main" val="0"/>
+            </a:ext>
+          </a:extLst>
+        </p:spPr>
+        <p:txBody>
+          <a:bodyPr lIns="0" tIns="0" rIns="0" bIns="0" anchor="ctr"/>
+          <a:lstStyle>
+            <a:lvl1pPr>
+              <a:defRPr sz="1000">
+                <a:solidFill>
+                  <a:schemeClr val="accent5"/>
+                </a:solidFill>
+              </a:defRPr>
+            </a:lvl1pPr>
+          </a:lstStyle>
+          <a:p>
+            <a:pPr algn="r"/>
+            <a:fld id="{F7021451-1387-4CA6-816F-3879F97B5CBC}" type="slidenum">
+              <a:rPr b="0" lang="en-US"/>
+              <a:t>11</a:t>
+            </a:fld>
+            <a:endParaRPr lang="en-US"/>
           </a:p>
         </p:txBody>
       </p:sp>
@@ -3576,7 +5028,7 @@
       </p:sp>
       <p:pic>
         <p:nvPicPr>
-          <p:cNvPr id="5" name="Icono FaClock" descr="preencoded.png">    </p:cNvPr>
+          <p:cNvPr id="5" name="Icono FaClock" descr="Icono de reloj">    </p:cNvPr>
           <p:cNvPicPr>
             <a:picLocks noChangeAspect="1"/>
           </p:cNvPicPr>
@@ -3725,7 +5177,7 @@
       </p:sp>
       <p:pic>
         <p:nvPicPr>
-          <p:cNvPr id="10" name="Icono FaMicrochip" descr="preencoded.png">    </p:cNvPr>
+          <p:cNvPr id="10" name="Icono FaMicrochip" descr="Icono de chip">    </p:cNvPr>
           <p:cNvPicPr>
             <a:picLocks noChangeAspect="1"/>
           </p:cNvPicPr>
@@ -3874,7 +5326,7 @@
       </p:sp>
       <p:pic>
         <p:nvPicPr>
-          <p:cNvPr id="15" name="Icono FaCoins" descr="preencoded.png">    </p:cNvPr>
+          <p:cNvPr id="15" name="Icono FaCoins" descr="Icono de monedas">    </p:cNvPr>
           <p:cNvPicPr>
             <a:picLocks noChangeAspect="1"/>
           </p:cNvPicPr>
@@ -4023,7 +5475,7 @@
       </p:sp>
       <p:pic>
         <p:nvPicPr>
-          <p:cNvPr id="20" name="Icono FaShapes" descr="preencoded.png">    </p:cNvPr>
+          <p:cNvPr id="20" name="Icono FaShapes" descr="Icono de formas geométricas">    </p:cNvPr>
           <p:cNvPicPr>
             <a:picLocks noChangeAspect="1"/>
           </p:cNvPicPr>
@@ -4172,7 +5624,7 @@
       </p:sp>
       <p:pic>
         <p:nvPicPr>
-          <p:cNvPr id="25" name="Icono FaFileZipper" descr="preencoded.png">    </p:cNvPr>
+          <p:cNvPr id="25" name="Icono FaFileZipper" descr="Icono de archivo comprimido">    </p:cNvPr>
           <p:cNvPicPr>
             <a:picLocks noChangeAspect="1"/>
           </p:cNvPicPr>
@@ -4321,7 +5773,7 @@
       </p:sp>
       <p:pic>
         <p:nvPicPr>
-          <p:cNvPr id="30" name="Icono FaGaugeHigh" descr="preencoded.png">    </p:cNvPr>
+          <p:cNvPr id="30" name="Icono FaGaugeHigh" descr="Icono de velocímetro">    </p:cNvPr>
           <p:cNvPicPr>
             <a:picLocks noChangeAspect="1"/>
           </p:cNvPicPr>
@@ -4578,7 +6030,7 @@
       </p:sp>
       <p:pic>
         <p:nvPicPr>
-          <p:cNvPr id="5" name="Icono FaBullseye" descr="preencoded.png">    </p:cNvPr>
+          <p:cNvPr id="5" name="Icono FaBullseye" descr="Icono de diana">    </p:cNvPr>
           <p:cNvPicPr>
             <a:picLocks noChangeAspect="1"/>
           </p:cNvPicPr>
@@ -4727,7 +6179,7 @@
       </p:sp>
       <p:pic>
         <p:nvPicPr>
-          <p:cNvPr id="10" name="Icono FaCode" descr="preencoded.png">    </p:cNvPr>
+          <p:cNvPr id="10" name="Icono FaCode" descr="Icono de código">    </p:cNvPr>
           <p:cNvPicPr>
             <a:picLocks noChangeAspect="1"/>
           </p:cNvPicPr>
@@ -4876,7 +6328,7 @@
       </p:sp>
       <p:pic>
         <p:nvPicPr>
-          <p:cNvPr id="15" name="Icono FaScaleBalanced" descr="preencoded.png">    </p:cNvPr>
+          <p:cNvPr id="15" name="Icono FaScaleBalanced" descr="Icono de balanza">    </p:cNvPr>
           <p:cNvPicPr>
             <a:picLocks noChangeAspect="1"/>
           </p:cNvPicPr>
@@ -5025,7 +6477,7 @@
       </p:sp>
       <p:pic>
         <p:nvPicPr>
-          <p:cNvPr id="20" name="Icono FaCameraRetro" descr="preencoded.png">    </p:cNvPr>
+          <p:cNvPr id="20" name="Icono FaCameraRetro" descr="Icono de cámara">    </p:cNvPr>
           <p:cNvPicPr>
             <a:picLocks noChangeAspect="1"/>
           </p:cNvPicPr>
@@ -5119,7 +6571,7 @@
                 <a:ea typeface="+mn-lt" pitchFamily="34" charset="-122"/>
                 <a:cs typeface="+mn-lt" pitchFamily="34" charset="-120"/>
               </a:rPr>
-              <a:t>Que alguien sin contexto vea la imagen y diga «es una foto».</a:t>
+              <a:t>Que alguien sin contexto vea la imagen y diga «es una foto».</a:t>
             </a:r>
             <a:endParaRPr lang="en-US" sz="1600" dirty="0"/>
           </a:p>
@@ -5984,7 +7436,7 @@
       </p:sp>
       <p:pic>
         <p:nvPicPr>
-          <p:cNvPr id="26" name="Icono FaCameraRetro" descr="preencoded.png">    </p:cNvPr>
+          <p:cNvPr id="26" name="Icono FaCameraRetro" descr="Icono de cámara">    </p:cNvPr>
           <p:cNvPicPr>
             <a:picLocks noChangeAspect="1"/>
           </p:cNvPicPr>
@@ -6584,7 +8036,7 @@
                 <a:ea typeface="+mn-lt" pitchFamily="34" charset="-122"/>
                 <a:cs typeface="+mn-lt" pitchFamily="34" charset="-120"/>
               </a:rPr>
-              <a:t>Las tres tandas de stills son la entrega y dos revisiones. Suman unos 425 minutos, ~7 h de GPU.</a:t>
+              <a:t>Las tres tandas de stills son la entrega y dos revisiones. En total, los renders suman unos 425 minutos (~7 h de GPU).</a:t>
             </a:r>
             <a:endParaRPr lang="en-US" sz="1400" dirty="0"/>
           </a:p>
@@ -7397,7 +8849,7 @@
       </p:sp>
       <p:pic>
         <p:nvPicPr>
-          <p:cNvPr id="5" name="Icono FaImage" descr="preencoded.png">    </p:cNvPr>
+          <p:cNvPr id="5" name="Icono FaImage" descr="Icono de imagen">    </p:cNvPr>
           <p:cNvPicPr>
             <a:picLocks noChangeAspect="1"/>
           </p:cNvPicPr>
@@ -7559,7 +9011,7 @@
       </p:sp>
       <p:pic>
         <p:nvPicPr>
-          <p:cNvPr id="10" name="Icono FaPalette" descr="preencoded.png">    </p:cNvPr>
+          <p:cNvPr id="10" name="Icono FaPalette" descr="Icono de paleta">    </p:cNvPr>
           <p:cNvPicPr>
             <a:picLocks noChangeAspect="1"/>
           </p:cNvPicPr>
@@ -7721,7 +9173,7 @@
       </p:sp>
       <p:pic>
         <p:nvPicPr>
-          <p:cNvPr id="15" name="Icono FaFileZipper" descr="preencoded.png">    </p:cNvPr>
+          <p:cNvPr id="15" name="Icono FaFileZipper" descr="Icono de archivo comprimido">    </p:cNvPr>
           <p:cNvPicPr>
             <a:picLocks noChangeAspect="1"/>
           </p:cNvPicPr>
@@ -7883,7 +9335,7 @@
       </p:sp>
       <p:pic>
         <p:nvPicPr>
-          <p:cNvPr id="20" name="Icono FaGaugeHigh" descr="preencoded.png">    </p:cNvPr>
+          <p:cNvPr id="20" name="Icono FaGaugeHigh" descr="Icono de velocímetro">    </p:cNvPr>
           <p:cNvPicPr>
             <a:picLocks noChangeAspect="1"/>
           </p:cNvPicPr>
@@ -8045,7 +9497,7 @@
       </p:sp>
       <p:pic>
         <p:nvPicPr>
-          <p:cNvPr id="25" name="Icono FaCircleCheck" descr="preencoded.png">    </p:cNvPr>
+          <p:cNvPr id="25" name="Icono FaCircleCheck" descr="Icono de verificación">    </p:cNvPr>
           <p:cNvPicPr>
             <a:picLocks noChangeAspect="1"/>
           </p:cNvPicPr>
@@ -8172,8 +9624,9 @@
         </p:nvPicPr>
         <p:blipFill>
           <a:blip r:embed="rId6"/>
-          <a:srcRect l="0" r="0" t="0" b="0"/>
-          <a:stretch/>
+          <a:stretch>
+            <a:fillRect/>
+          </a:stretch>
         </p:blipFill>
         <p:spPr>
           <a:xfrm>
@@ -8323,10 +9776,10 @@
             <a:r>
               <a:rPr lang="en-US" sz="3600" b="1" dirty="0">
                 <a:solidFill>
-                  <a:schemeClr val="tx1"/>
-                </a:solidFill>
-              </a:rPr>
-              <a:t>Entregables listos para usar</a:t>
+                  <a:schemeClr val="bg1"/>
+                </a:solidFill>
+              </a:rPr>
+              <a:t>El plató completo en 360°</a:t>
             </a:r>
             <a:endParaRPr lang="en-US" sz="3600" dirty="0"/>
           </a:p>
@@ -8334,7 +9787,7 @@
       </p:sp>
       <p:pic>
         <p:nvPicPr>
-          <p:cNvPr id="3" name="Foto CAM_02" descr="Plano general del plató con la pantalla del estadio, la mesa sobre su tarima y las vitrinas azules">    </p:cNvPr>
+          <p:cNvPr id="3" name="Foto panorámica 360" descr="Panorámica 360° del plató: zona de entrevistas con sofá a la izquierda, mesa principal bajo el halo de luz en el centro, y mueble de madera, pantalla del estadio y escalera con mosaico LED a la derecha">    </p:cNvPr>
           <p:cNvPicPr>
             <a:picLocks noChangeAspect="1"/>
           </p:cNvPicPr>
@@ -8342,96 +9795,14 @@
         </p:nvPicPr>
         <p:blipFill>
           <a:blip r:embed="rId1"/>
-          <a:srcRect l="0" r="0" t="0" b="0"/>
-          <a:stretch/>
-        </p:blipFill>
-        <p:spPr>
-          <a:xfrm>
-            <a:off x="548640" y="1463040"/>
-            <a:ext cx="6309360" cy="4069080"/>
-          </a:xfrm>
-          <a:prstGeom prst="rect">
-            <a:avLst/>
-          </a:prstGeom>
-        </p:spPr>
-      </p:pic>
-      <p:sp>
-        <p:nvSpPr>
-          <p:cNvPr id="4" name="Pie CAM_02"/>
-          <p:cNvSpPr txBox="1"/>
-          <p:nvPr/>
-        </p:nvSpPr>
-        <p:spPr>
-          <a:xfrm>
-            <a:off x="548640" y="5623560"/>
-            <a:ext cx="6309360" cy="274320"/>
-          </a:xfrm>
-          <a:prstGeom prst="rect">
-            <a:avLst/>
-          </a:prstGeom>
-          <a:noFill/>
-          <a:ln/>
-        </p:spPr>
-        <p:txBody>
-          <a:bodyPr wrap="square" lIns="0" tIns="0" rIns="0" bIns="0" rtlCol="0" anchor="ctr"/>
-          <a:lstStyle/>
-          <a:p>
-            <a:pPr indent="0" marL="0">
-              <a:buNone/>
-            </a:pPr>
-            <a:r>
-              <a:rPr lang="en-US" sz="1200" dirty="0">
-                <a:solidFill>
-                  <a:schemeClr val="accent4"/>
-                </a:solidFill>
-                <a:latin typeface="+mn-lt" pitchFamily="34" charset="0"/>
-                <a:ea typeface="+mn-lt" pitchFamily="34" charset="-122"/>
-                <a:cs typeface="+mn-lt" pitchFamily="34" charset="-120"/>
-              </a:rPr>
-              <a:t>Plano general (CAM_02).</a:t>
-            </a:r>
-            <a:endParaRPr lang="en-US" sz="1200" dirty="0"/>
-          </a:p>
-        </p:txBody>
-      </p:sp>
-      <p:sp>
-        <p:nvSpPr>
-          <p:cNvPr id="5" name="Círculo FaCube"/>
-          <p:cNvSpPr/>
-          <p:nvPr/>
-        </p:nvSpPr>
-        <p:spPr>
-          <a:xfrm>
-            <a:off x="7223760" y="1508760"/>
-            <a:ext cx="548640" cy="548640"/>
-          </a:xfrm>
-          <a:prstGeom prst="ellipse">
-            <a:avLst/>
-          </a:prstGeom>
-          <a:solidFill>
-            <a:schemeClr val="accent6"/>
-          </a:solidFill>
-          <a:ln/>
-        </p:spPr>
-      </p:sp>
-      <p:pic>
-        <p:nvPicPr>
-          <p:cNvPr id="6" name="Icono FaCube" descr="preencoded.png">    </p:cNvPr>
-          <p:cNvPicPr>
-            <a:picLocks noChangeAspect="1"/>
-          </p:cNvPicPr>
-          <p:nvPr/>
-        </p:nvPicPr>
-        <p:blipFill>
-          <a:blip r:embed="rId2"/>
           <a:stretch>
             <a:fillRect/>
           </a:stretch>
         </p:blipFill>
         <p:spPr>
           <a:xfrm>
-            <a:off x="7360920" y="1645920"/>
-            <a:ext cx="274320" cy="274320"/>
+            <a:off x="548640" y="1371600"/>
+            <a:ext cx="11094415" cy="4480560"/>
           </a:xfrm>
           <a:prstGeom prst="rect">
             <a:avLst/>
@@ -8440,14 +9811,14 @@
       </p:pic>
       <p:sp>
         <p:nvSpPr>
-          <p:cNvPr id="7" name="Título Escena de Blender"/>
+          <p:cNvPr id="4" name="Pie panorámica"/>
           <p:cNvSpPr txBox="1"/>
           <p:nvPr/>
         </p:nvSpPr>
         <p:spPr>
           <a:xfrm>
-            <a:off x="8001000" y="1508760"/>
-            <a:ext cx="3642055" cy="384048"/>
+            <a:off x="548640" y="5961888"/>
+            <a:ext cx="11094415" cy="274320"/>
           </a:xfrm>
           <a:prstGeom prst="rect">
             <a:avLst/>
@@ -8463,422 +9834,17 @@
               <a:buNone/>
             </a:pPr>
             <a:r>
-              <a:rPr lang="en-US" sz="1800" b="1" dirty="0">
-                <a:solidFill>
-                  <a:schemeClr val="tx1"/>
-                </a:solidFill>
-                <a:latin typeface="+mj-lt" pitchFamily="34" charset="0"/>
-                <a:ea typeface="+mj-lt" pitchFamily="34" charset="-122"/>
-                <a:cs typeface="+mj-lt" pitchFamily="34" charset="-120"/>
-              </a:rPr>
-              <a:t>Escena de Blender</a:t>
-            </a:r>
-            <a:endParaRPr lang="en-US" sz="1800" dirty="0"/>
-          </a:p>
-        </p:txBody>
-      </p:sp>
-      <p:sp>
-        <p:nvSpPr>
-          <p:cNvPr id="8" name="Texto Escena de Blender"/>
-          <p:cNvSpPr txBox="1"/>
-          <p:nvPr/>
-        </p:nvSpPr>
-        <p:spPr>
-          <a:xfrm>
-            <a:off x="8001000" y="1920240"/>
-            <a:ext cx="3642055" cy="571500"/>
-          </a:xfrm>
-          <a:prstGeom prst="rect">
-            <a:avLst/>
-          </a:prstGeom>
-          <a:noFill/>
-          <a:ln/>
-        </p:spPr>
-        <p:txBody>
-          <a:bodyPr wrap="square" lIns="0" tIns="0" rIns="0" bIns="0" rtlCol="0" anchor="t"/>
-          <a:lstStyle/>
-          <a:p>
-            <a:pPr indent="0" marL="0">
-              <a:buNone/>
-            </a:pPr>
-            <a:r>
-              <a:rPr lang="en-US" sz="1500" dirty="0">
-                <a:solidFill>
-                  <a:schemeClr val="tx1"/>
+              <a:rPr lang="en-US" sz="1200" dirty="0">
+                <a:solidFill>
+                  <a:schemeClr val="accent5"/>
                 </a:solidFill>
                 <a:latin typeface="+mn-lt" pitchFamily="34" charset="0"/>
                 <a:ea typeface="+mn-lt" pitchFamily="34" charset="-122"/>
                 <a:cs typeface="+mn-lt" pitchFamily="34" charset="-120"/>
               </a:rPr>
-              <a:t>Empaquetada y lista para abrir, con un espacio de trabajo preparado para recorrerla.</a:t>
-            </a:r>
-            <a:endParaRPr lang="en-US" sz="1500" dirty="0"/>
-          </a:p>
-        </p:txBody>
-      </p:sp>
-      <p:sp>
-        <p:nvSpPr>
-          <p:cNvPr id="9" name="Círculo FaImages"/>
-          <p:cNvSpPr/>
-          <p:nvPr/>
-        </p:nvSpPr>
-        <p:spPr>
-          <a:xfrm>
-            <a:off x="7223760" y="2628900"/>
-            <a:ext cx="548640" cy="548640"/>
-          </a:xfrm>
-          <a:prstGeom prst="ellipse">
-            <a:avLst/>
-          </a:prstGeom>
-          <a:solidFill>
-            <a:schemeClr val="accent6"/>
-          </a:solidFill>
-          <a:ln/>
-        </p:spPr>
-      </p:sp>
-      <p:pic>
-        <p:nvPicPr>
-          <p:cNvPr id="10" name="Icono FaImages" descr="preencoded.png">    </p:cNvPr>
-          <p:cNvPicPr>
-            <a:picLocks noChangeAspect="1"/>
-          </p:cNvPicPr>
-          <p:nvPr/>
-        </p:nvPicPr>
-        <p:blipFill>
-          <a:blip r:embed="rId3"/>
-          <a:stretch>
-            <a:fillRect/>
-          </a:stretch>
-        </p:blipFill>
-        <p:spPr>
-          <a:xfrm>
-            <a:off x="7360920" y="2766060"/>
-            <a:ext cx="274320" cy="274320"/>
-          </a:xfrm>
-          <a:prstGeom prst="rect">
-            <a:avLst/>
-          </a:prstGeom>
-        </p:spPr>
-      </p:pic>
-      <p:sp>
-        <p:nvSpPr>
-          <p:cNvPr id="11" name="Título Seis imágenes finales"/>
-          <p:cNvSpPr txBox="1"/>
-          <p:nvPr/>
-        </p:nvSpPr>
-        <p:spPr>
-          <a:xfrm>
-            <a:off x="8001000" y="2628900"/>
-            <a:ext cx="3642055" cy="384048"/>
-          </a:xfrm>
-          <a:prstGeom prst="rect">
-            <a:avLst/>
-          </a:prstGeom>
-          <a:noFill/>
-          <a:ln/>
-        </p:spPr>
-        <p:txBody>
-          <a:bodyPr wrap="square" lIns="0" tIns="0" rIns="0" bIns="0" rtlCol="0" anchor="ctr"/>
-          <a:lstStyle/>
-          <a:p>
-            <a:pPr indent="0" marL="0">
-              <a:buNone/>
-            </a:pPr>
-            <a:r>
-              <a:rPr lang="en-US" sz="1800" b="1" dirty="0">
-                <a:solidFill>
-                  <a:schemeClr val="tx1"/>
-                </a:solidFill>
-                <a:latin typeface="+mj-lt" pitchFamily="34" charset="0"/>
-                <a:ea typeface="+mj-lt" pitchFamily="34" charset="-122"/>
-                <a:cs typeface="+mj-lt" pitchFamily="34" charset="-120"/>
-              </a:rPr>
-              <a:t>Seis imágenes finales</a:t>
-            </a:r>
-            <a:endParaRPr lang="en-US" sz="1800" dirty="0"/>
-          </a:p>
-        </p:txBody>
-      </p:sp>
-      <p:sp>
-        <p:nvSpPr>
-          <p:cNvPr id="12" name="Texto Seis imágenes finales"/>
-          <p:cNvSpPr txBox="1"/>
-          <p:nvPr/>
-        </p:nvSpPr>
-        <p:spPr>
-          <a:xfrm>
-            <a:off x="8001000" y="3040380"/>
-            <a:ext cx="3642055" cy="571500"/>
-          </a:xfrm>
-          <a:prstGeom prst="rect">
-            <a:avLst/>
-          </a:prstGeom>
-          <a:noFill/>
-          <a:ln/>
-        </p:spPr>
-        <p:txBody>
-          <a:bodyPr wrap="square" lIns="0" tIns="0" rIns="0" bIns="0" rtlCol="0" anchor="t"/>
-          <a:lstStyle/>
-          <a:p>
-            <a:pPr indent="0" marL="0">
-              <a:buNone/>
-            </a:pPr>
-            <a:r>
-              <a:rPr lang="en-US" sz="1500" dirty="0">
-                <a:solidFill>
-                  <a:schemeClr val="tx1"/>
-                </a:solidFill>
-                <a:latin typeface="+mn-lt" pitchFamily="34" charset="0"/>
-                <a:ea typeface="+mn-lt" pitchFamily="34" charset="-122"/>
-                <a:cs typeface="+mn-lt" pitchFamily="34" charset="-120"/>
-              </a:rPr>
-              <a:t>Cinco en 4K y una panorámica 360°, en formato de edición y en PNG.</a:t>
-            </a:r>
-            <a:endParaRPr lang="en-US" sz="1500" dirty="0"/>
-          </a:p>
-        </p:txBody>
-      </p:sp>
-      <p:sp>
-        <p:nvSpPr>
-          <p:cNvPr id="13" name="Círculo FaFilm"/>
-          <p:cNvSpPr/>
-          <p:nvPr/>
-        </p:nvSpPr>
-        <p:spPr>
-          <a:xfrm>
-            <a:off x="7223760" y="3749040"/>
-            <a:ext cx="548640" cy="548640"/>
-          </a:xfrm>
-          <a:prstGeom prst="ellipse">
-            <a:avLst/>
-          </a:prstGeom>
-          <a:solidFill>
-            <a:schemeClr val="accent6"/>
-          </a:solidFill>
-          <a:ln/>
-        </p:spPr>
-      </p:sp>
-      <p:pic>
-        <p:nvPicPr>
-          <p:cNvPr id="14" name="Icono FaFilm" descr="preencoded.png">    </p:cNvPr>
-          <p:cNvPicPr>
-            <a:picLocks noChangeAspect="1"/>
-          </p:cNvPicPr>
-          <p:nvPr/>
-        </p:nvPicPr>
-        <p:blipFill>
-          <a:blip r:embed="rId4"/>
-          <a:stretch>
-            <a:fillRect/>
-          </a:stretch>
-        </p:blipFill>
-        <p:spPr>
-          <a:xfrm>
-            <a:off x="7360920" y="3886200"/>
-            <a:ext cx="274320" cy="274320"/>
-          </a:xfrm>
-          <a:prstGeom prst="rect">
-            <a:avLst/>
-          </a:prstGeom>
-        </p:spPr>
-      </p:pic>
-      <p:sp>
-        <p:nvSpPr>
-          <p:cNvPr id="15" name="Título Vídeo de 45 s"/>
-          <p:cNvSpPr txBox="1"/>
-          <p:nvPr/>
-        </p:nvSpPr>
-        <p:spPr>
-          <a:xfrm>
-            <a:off x="8001000" y="3749040"/>
-            <a:ext cx="3642055" cy="384048"/>
-          </a:xfrm>
-          <a:prstGeom prst="rect">
-            <a:avLst/>
-          </a:prstGeom>
-          <a:noFill/>
-          <a:ln/>
-        </p:spPr>
-        <p:txBody>
-          <a:bodyPr wrap="square" lIns="0" tIns="0" rIns="0" bIns="0" rtlCol="0" anchor="ctr"/>
-          <a:lstStyle/>
-          <a:p>
-            <a:pPr indent="0" marL="0">
-              <a:buNone/>
-            </a:pPr>
-            <a:r>
-              <a:rPr lang="en-US" sz="1800" b="1" dirty="0">
-                <a:solidFill>
-                  <a:schemeClr val="tx1"/>
-                </a:solidFill>
-                <a:latin typeface="+mj-lt" pitchFamily="34" charset="0"/>
-                <a:ea typeface="+mj-lt" pitchFamily="34" charset="-122"/>
-                <a:cs typeface="+mj-lt" pitchFamily="34" charset="-120"/>
-              </a:rPr>
-              <a:t>Vídeo de 45 s</a:t>
-            </a:r>
-            <a:endParaRPr lang="en-US" sz="1800" dirty="0"/>
-          </a:p>
-        </p:txBody>
-      </p:sp>
-      <p:sp>
-        <p:nvSpPr>
-          <p:cNvPr id="16" name="Texto Vídeo de 45 s"/>
-          <p:cNvSpPr txBox="1"/>
-          <p:nvPr/>
-        </p:nvSpPr>
-        <p:spPr>
-          <a:xfrm>
-            <a:off x="8001000" y="4160520"/>
-            <a:ext cx="3642055" cy="571500"/>
-          </a:xfrm>
-          <a:prstGeom prst="rect">
-            <a:avLst/>
-          </a:prstGeom>
-          <a:noFill/>
-          <a:ln/>
-        </p:spPr>
-        <p:txBody>
-          <a:bodyPr wrap="square" lIns="0" tIns="0" rIns="0" bIns="0" rtlCol="0" anchor="t"/>
-          <a:lstStyle/>
-          <a:p>
-            <a:pPr indent="0" marL="0">
-              <a:buNone/>
-            </a:pPr>
-            <a:r>
-              <a:rPr lang="en-US" sz="1500" dirty="0">
-                <a:solidFill>
-                  <a:schemeClr val="tx1"/>
-                </a:solidFill>
-                <a:latin typeface="+mn-lt" pitchFamily="34" charset="0"/>
-                <a:ea typeface="+mn-lt" pitchFamily="34" charset="-122"/>
-                <a:cs typeface="+mn-lt" pitchFamily="34" charset="-120"/>
-              </a:rPr>
-              <a:t>Recorrido aéreo, más tres animaciones de cámara listas para renderizar.</a:t>
-            </a:r>
-            <a:endParaRPr lang="en-US" sz="1500" dirty="0"/>
-          </a:p>
-        </p:txBody>
-      </p:sp>
-      <p:sp>
-        <p:nvSpPr>
-          <p:cNvPr id="17" name="Círculo FaFileLines"/>
-          <p:cNvSpPr/>
-          <p:nvPr/>
-        </p:nvSpPr>
-        <p:spPr>
-          <a:xfrm>
-            <a:off x="7223760" y="4869180"/>
-            <a:ext cx="548640" cy="548640"/>
-          </a:xfrm>
-          <a:prstGeom prst="ellipse">
-            <a:avLst/>
-          </a:prstGeom>
-          <a:solidFill>
-            <a:schemeClr val="accent6"/>
-          </a:solidFill>
-          <a:ln/>
-        </p:spPr>
-      </p:sp>
-      <p:pic>
-        <p:nvPicPr>
-          <p:cNvPr id="18" name="Icono FaFileLines" descr="preencoded.png">    </p:cNvPr>
-          <p:cNvPicPr>
-            <a:picLocks noChangeAspect="1"/>
-          </p:cNvPicPr>
-          <p:nvPr/>
-        </p:nvPicPr>
-        <p:blipFill>
-          <a:blip r:embed="rId5"/>
-          <a:stretch>
-            <a:fillRect/>
-          </a:stretch>
-        </p:blipFill>
-        <p:spPr>
-          <a:xfrm>
-            <a:off x="7360920" y="5006340"/>
-            <a:ext cx="274320" cy="274320"/>
-          </a:xfrm>
-          <a:prstGeom prst="rect">
-            <a:avLst/>
-          </a:prstGeom>
-        </p:spPr>
-      </p:pic>
-      <p:sp>
-        <p:nvSpPr>
-          <p:cNvPr id="19" name="Título Documentación"/>
-          <p:cNvSpPr txBox="1"/>
-          <p:nvPr/>
-        </p:nvSpPr>
-        <p:spPr>
-          <a:xfrm>
-            <a:off x="8001000" y="4869180"/>
-            <a:ext cx="3642055" cy="384048"/>
-          </a:xfrm>
-          <a:prstGeom prst="rect">
-            <a:avLst/>
-          </a:prstGeom>
-          <a:noFill/>
-          <a:ln/>
-        </p:spPr>
-        <p:txBody>
-          <a:bodyPr wrap="square" lIns="0" tIns="0" rIns="0" bIns="0" rtlCol="0" anchor="ctr"/>
-          <a:lstStyle/>
-          <a:p>
-            <a:pPr indent="0" marL="0">
-              <a:buNone/>
-            </a:pPr>
-            <a:r>
-              <a:rPr lang="en-US" sz="1800" b="1" dirty="0">
-                <a:solidFill>
-                  <a:schemeClr val="tx1"/>
-                </a:solidFill>
-                <a:latin typeface="+mj-lt" pitchFamily="34" charset="0"/>
-                <a:ea typeface="+mj-lt" pitchFamily="34" charset="-122"/>
-                <a:cs typeface="+mj-lt" pitchFamily="34" charset="-120"/>
-              </a:rPr>
-              <a:t>Documentación</a:t>
-            </a:r>
-            <a:endParaRPr lang="en-US" sz="1800" dirty="0"/>
-          </a:p>
-        </p:txBody>
-      </p:sp>
-      <p:sp>
-        <p:nvSpPr>
-          <p:cNvPr id="20" name="Texto Documentación"/>
-          <p:cNvSpPr txBox="1"/>
-          <p:nvPr/>
-        </p:nvSpPr>
-        <p:spPr>
-          <a:xfrm>
-            <a:off x="8001000" y="5280660"/>
-            <a:ext cx="3642055" cy="571500"/>
-          </a:xfrm>
-          <a:prstGeom prst="rect">
-            <a:avLst/>
-          </a:prstGeom>
-          <a:noFill/>
-          <a:ln/>
-        </p:spPr>
-        <p:txBody>
-          <a:bodyPr wrap="square" lIns="0" tIns="0" rIns="0" bIns="0" rtlCol="0" anchor="t"/>
-          <a:lstStyle/>
-          <a:p>
-            <a:pPr indent="0" marL="0">
-              <a:buNone/>
-            </a:pPr>
-            <a:r>
-              <a:rPr lang="en-US" sz="1500" dirty="0">
-                <a:solidFill>
-                  <a:schemeClr val="tx1"/>
-                </a:solidFill>
-                <a:latin typeface="+mn-lt" pitchFamily="34" charset="0"/>
-                <a:ea typeface="+mn-lt" pitchFamily="34" charset="-122"/>
-                <a:cs typeface="+mn-lt" pitchFamily="34" charset="-120"/>
-              </a:rPr>
-              <a:t>Guía de uso, créditos y licencias, e informe de calidad fase por fase.</a:t>
-            </a:r>
-            <a:endParaRPr lang="en-US" sz="1500" dirty="0"/>
+              <a:t>Panorámica 360°: la mesa principal en el centro, la zona de entrevistas a la izquierda y la escalera con el mosaico LED a la derecha.</a:t>
+            </a:r>
+            <a:endParaRPr lang="en-US" sz="1200" dirty="0"/>
           </a:p>
         </p:txBody>
       </p:sp>
@@ -8912,7 +9878,7 @@
             <a:lvl1pPr>
               <a:defRPr sz="1000">
                 <a:solidFill>
-                  <a:schemeClr val="accent4"/>
+                  <a:schemeClr val="accent5"/>
                 </a:solidFill>
               </a:defRPr>
             </a:lvl1pPr>
@@ -8984,66 +9950,15 @@
                   <a:schemeClr val="bg1"/>
                 </a:solidFill>
               </a:rPr>
-              <a:t>Siguientes pasos</a:t>
+              <a:t>Otros ángulos del plató</a:t>
             </a:r>
             <a:endParaRPr lang="en-US" sz="3600" dirty="0"/>
           </a:p>
         </p:txBody>
-      </p:sp>
-      <p:sp>
-        <p:nvSpPr>
-          <p:cNvPr id="3" name="Tarjeta prueba final"/>
-          <p:cNvSpPr/>
-          <p:nvPr/>
-        </p:nvSpPr>
-        <p:spPr>
-          <a:xfrm>
-            <a:off x="548640" y="1554480"/>
-            <a:ext cx="5410048" cy="3749040"/>
-          </a:xfrm>
-          <a:prstGeom prst="roundRect">
-            <a:avLst>
-              <a:gd name="adj" fmla="val 1951"/>
-            </a:avLst>
-          </a:prstGeom>
-          <a:solidFill>
-            <a:schemeClr val="bg1">
-              <a:alpha val="8000"/>
-            </a:schemeClr>
-          </a:solidFill>
-          <a:ln w="9525">
-            <a:solidFill>
-              <a:schemeClr val="bg1">
-                <a:alpha val="20000"/>
-              </a:schemeClr>
-            </a:solidFill>
-            <a:prstDash val="solid"/>
-          </a:ln>
-        </p:spPr>
-      </p:sp>
-      <p:sp>
-        <p:nvSpPr>
-          <p:cNvPr id="4" name="Círculo FaUserCheck"/>
-          <p:cNvSpPr/>
-          <p:nvPr/>
-        </p:nvSpPr>
-        <p:spPr>
-          <a:xfrm>
-            <a:off x="914400" y="1920240"/>
-            <a:ext cx="603504" cy="603504"/>
-          </a:xfrm>
-          <a:prstGeom prst="ellipse">
-            <a:avLst/>
-          </a:prstGeom>
-          <a:solidFill>
-            <a:schemeClr val="accent1"/>
-          </a:solidFill>
-          <a:ln/>
-        </p:spPr>
       </p:sp>
       <p:pic>
         <p:nvPicPr>
-          <p:cNvPr id="5" name="Icono FaUserCheck" descr="preencoded.png">    </p:cNvPr>
+          <p:cNvPr id="3" name="Foto vista_entrevistas_32.jpg" descr="Vista lateral del plató: sofá blanco con cojines sobre tarima de mármol, escalera con barandilla de vidrio, mosaico LED, pantallas y la mesa principal con sillas blancas a la derecha">    </p:cNvPr>
           <p:cNvPicPr>
             <a:picLocks noChangeAspect="1"/>
           </p:cNvPicPr>
@@ -9057,8 +9972,8 @@
         </p:blipFill>
         <p:spPr>
           <a:xfrm>
-            <a:off x="1065276" y="2071116"/>
-            <a:ext cx="301752" cy="301752"/>
+            <a:off x="548640" y="1371600"/>
+            <a:ext cx="5410048" cy="3606698"/>
           </a:xfrm>
           <a:prstGeom prst="rect">
             <a:avLst/>
@@ -9067,175 +9982,46 @@
       </p:pic>
       <p:sp>
         <p:nvSpPr>
-          <p:cNvPr id="6" name="Título paso 1"/>
+          <p:cNvPr id="4" name="Pie vista_entrevistas_32.jpg"/>
           <p:cNvSpPr txBox="1"/>
           <p:nvPr/>
         </p:nvSpPr>
         <p:spPr>
           <a:xfrm>
-            <a:off x="1737360" y="1920240"/>
-            <a:ext cx="3855568" cy="603504"/>
-          </a:xfrm>
-          <a:prstGeom prst="rect">
-            <a:avLst/>
-          </a:prstGeom>
-          <a:noFill/>
-          <a:ln/>
-        </p:spPr>
-        <p:txBody>
-          <a:bodyPr wrap="square" lIns="0" tIns="0" rIns="0" bIns="0" rtlCol="0" anchor="ctr"/>
+            <a:off x="548640" y="5088026"/>
+            <a:ext cx="5410048" cy="457200"/>
+          </a:xfrm>
+          <a:prstGeom prst="rect">
+            <a:avLst/>
+          </a:prstGeom>
+          <a:noFill/>
+          <a:ln/>
+        </p:spPr>
+        <p:txBody>
+          <a:bodyPr wrap="square" lIns="0" tIns="0" rIns="0" bIns="0" rtlCol="0" anchor="t"/>
           <a:lstStyle/>
           <a:p>
             <a:pPr indent="0" marL="0">
               <a:buNone/>
             </a:pPr>
             <a:r>
-              <a:rPr lang="en-US" sz="2400" b="1" dirty="0">
-                <a:solidFill>
-                  <a:schemeClr val="bg1"/>
-                </a:solidFill>
-                <a:latin typeface="+mj-lt" pitchFamily="34" charset="0"/>
-                <a:ea typeface="+mj-lt" pitchFamily="34" charset="-122"/>
-                <a:cs typeface="+mj-lt" pitchFamily="34" charset="-120"/>
-              </a:rPr>
-              <a:t>Repetir la prueba final</a:t>
-            </a:r>
-            <a:endParaRPr lang="en-US" sz="2400" dirty="0"/>
-          </a:p>
-        </p:txBody>
-      </p:sp>
-      <p:sp>
-        <p:nvSpPr>
-          <p:cNvPr id="7" name="Texto paso 1"/>
-          <p:cNvSpPr txBox="1"/>
-          <p:nvPr/>
-        </p:nvSpPr>
-        <p:spPr>
-          <a:xfrm>
-            <a:off x="914400" y="2788920"/>
-            <a:ext cx="4678528" cy="1005840"/>
-          </a:xfrm>
-          <a:prstGeom prst="rect">
-            <a:avLst/>
-          </a:prstGeom>
-          <a:noFill/>
-          <a:ln/>
-        </p:spPr>
-        <p:txBody>
-          <a:bodyPr wrap="square" lIns="0" tIns="0" rIns="0" bIns="0" rtlCol="0" anchor="t"/>
-          <a:lstStyle/>
-          <a:p>
-            <a:pPr indent="0" marL="0">
-              <a:buNone/>
-            </a:pPr>
-            <a:r>
-              <a:rPr lang="en-US" sz="1800" dirty="0">
-                <a:solidFill>
-                  <a:schemeClr val="bg2"/>
+              <a:rPr lang="en-US" sz="1200" dirty="0">
+                <a:solidFill>
+                  <a:schemeClr val="accent5"/>
                 </a:solidFill>
                 <a:latin typeface="+mn-lt" pitchFamily="34" charset="0"/>
                 <a:ea typeface="+mn-lt" pitchFamily="34" charset="-122"/>
                 <a:cs typeface="+mn-lt" pitchFamily="34" charset="-120"/>
               </a:rPr>
-              <a:t>Con las imágenes nuevas y con personas que no conozcan el proyecto. La respuesta que se busca:</a:t>
-            </a:r>
-            <a:endParaRPr lang="en-US" sz="1800" dirty="0"/>
-          </a:p>
-        </p:txBody>
-      </p:sp>
-      <p:sp>
-        <p:nvSpPr>
-          <p:cNvPr id="8" name="Cita objetivo"/>
-          <p:cNvSpPr txBox="1"/>
-          <p:nvPr/>
-        </p:nvSpPr>
-        <p:spPr>
-          <a:xfrm>
-            <a:off x="914400" y="3703320"/>
-            <a:ext cx="4678528" cy="822960"/>
-          </a:xfrm>
-          <a:prstGeom prst="rect">
-            <a:avLst/>
-          </a:prstGeom>
-          <a:noFill/>
-          <a:ln/>
-        </p:spPr>
-        <p:txBody>
-          <a:bodyPr wrap="square" lIns="0" tIns="0" rIns="0" bIns="0" rtlCol="0" anchor="ctr"/>
-          <a:lstStyle/>
-          <a:p>
-            <a:pPr indent="0" marL="0">
-              <a:buNone/>
-            </a:pPr>
-            <a:r>
-              <a:rPr lang="en-US" sz="4000" b="1" i="1" dirty="0">
-                <a:solidFill>
-                  <a:schemeClr val="accent3"/>
-                </a:solidFill>
-                <a:latin typeface="+mj-lt" pitchFamily="34" charset="0"/>
-                <a:ea typeface="+mj-lt" pitchFamily="34" charset="-122"/>
-                <a:cs typeface="+mj-lt" pitchFamily="34" charset="-120"/>
-              </a:rPr>
-              <a:t>«Es una foto»</a:t>
-            </a:r>
-            <a:endParaRPr lang="en-US" sz="4000" dirty="0"/>
-          </a:p>
-        </p:txBody>
-      </p:sp>
-      <p:sp>
-        <p:nvSpPr>
-          <p:cNvPr id="9" name="Tarjeta ahorro de espacio"/>
-          <p:cNvSpPr/>
-          <p:nvPr/>
-        </p:nvSpPr>
-        <p:spPr>
-          <a:xfrm>
-            <a:off x="6233008" y="1554480"/>
-            <a:ext cx="5410048" cy="3749040"/>
-          </a:xfrm>
-          <a:prstGeom prst="roundRect">
-            <a:avLst>
-              <a:gd name="adj" fmla="val 1951"/>
-            </a:avLst>
-          </a:prstGeom>
-          <a:solidFill>
-            <a:schemeClr val="bg1">
-              <a:alpha val="8000"/>
-            </a:schemeClr>
-          </a:solidFill>
-          <a:ln w="9525">
-            <a:solidFill>
-              <a:schemeClr val="bg1">
-                <a:alpha val="20000"/>
-              </a:schemeClr>
-            </a:solidFill>
-            <a:prstDash val="solid"/>
-          </a:ln>
-        </p:spPr>
-      </p:sp>
-      <p:sp>
-        <p:nvSpPr>
-          <p:cNvPr id="10" name="Círculo FaHardDrive"/>
-          <p:cNvSpPr/>
-          <p:nvPr/>
-        </p:nvSpPr>
-        <p:spPr>
-          <a:xfrm>
-            <a:off x="6598768" y="1920240"/>
-            <a:ext cx="603504" cy="603504"/>
-          </a:xfrm>
-          <a:prstGeom prst="ellipse">
-            <a:avLst/>
-          </a:prstGeom>
-          <a:solidFill>
-            <a:schemeClr val="accent1"/>
-          </a:solidFill>
-          <a:ln/>
-        </p:spPr>
+              <a:t>Zona de entrevistas: sofá sobre tarima de mármol, escalera con barandilla de vidrio y mosaico LED, con la mesa principal a la derecha.</a:t>
+            </a:r>
+            <a:endParaRPr lang="en-US" sz="1200" dirty="0"/>
+          </a:p>
+        </p:txBody>
       </p:sp>
       <p:pic>
         <p:nvPicPr>
-          <p:cNvPr id="11" name="Icono FaHardDrive" descr="preencoded.png">    </p:cNvPr>
+          <p:cNvPr id="5" name="Foto vista_mesa_32.jpg" descr="Vista desde la mesa de presentadores, con micrófonos y tableta en primer plano, hacia la pantalla del estadio, la escalera, el mosaico LED y el sofá">    </p:cNvPr>
           <p:cNvPicPr>
             <a:picLocks noChangeAspect="1"/>
           </p:cNvPicPr>
@@ -9249,8 +10035,8 @@
         </p:blipFill>
         <p:spPr>
           <a:xfrm>
-            <a:off x="6749644" y="2071116"/>
-            <a:ext cx="301752" cy="301752"/>
+            <a:off x="6233008" y="1371600"/>
+            <a:ext cx="5410048" cy="3606698"/>
           </a:xfrm>
           <a:prstGeom prst="rect">
             <a:avLst/>
@@ -9259,235 +10045,40 @@
       </p:pic>
       <p:sp>
         <p:nvSpPr>
-          <p:cNvPr id="12" name="Título paso 2"/>
+          <p:cNvPr id="6" name="Pie vista_mesa_32.jpg"/>
           <p:cNvSpPr txBox="1"/>
           <p:nvPr/>
         </p:nvSpPr>
         <p:spPr>
           <a:xfrm>
-            <a:off x="7421728" y="1920240"/>
-            <a:ext cx="3855568" cy="603504"/>
-          </a:xfrm>
-          <a:prstGeom prst="rect">
-            <a:avLst/>
-          </a:prstGeom>
-          <a:noFill/>
-          <a:ln/>
-        </p:spPr>
-        <p:txBody>
-          <a:bodyPr wrap="square" lIns="0" tIns="0" rIns="0" bIns="0" rtlCol="0" anchor="ctr"/>
+            <a:off x="6233008" y="5088026"/>
+            <a:ext cx="5410048" cy="457200"/>
+          </a:xfrm>
+          <a:prstGeom prst="rect">
+            <a:avLst/>
+          </a:prstGeom>
+          <a:noFill/>
+          <a:ln/>
+        </p:spPr>
+        <p:txBody>
+          <a:bodyPr wrap="square" lIns="0" tIns="0" rIns="0" bIns="0" rtlCol="0" anchor="t"/>
           <a:lstStyle/>
           <a:p>
             <a:pPr indent="0" marL="0">
               <a:buNone/>
             </a:pPr>
             <a:r>
-              <a:rPr lang="en-US" sz="2400" b="1" dirty="0">
-                <a:solidFill>
-                  <a:schemeClr val="bg1"/>
-                </a:solidFill>
-                <a:latin typeface="+mj-lt" pitchFamily="34" charset="0"/>
-                <a:ea typeface="+mj-lt" pitchFamily="34" charset="-122"/>
-                <a:cs typeface="+mj-lt" pitchFamily="34" charset="-120"/>
-              </a:rPr>
-              <a:t>Ahorrar espacio</a:t>
-            </a:r>
-            <a:endParaRPr lang="en-US" sz="2400" dirty="0"/>
-          </a:p>
-        </p:txBody>
-      </p:sp>
-      <p:sp>
-        <p:nvSpPr>
-          <p:cNvPr id="13" name="Cifra 16 GB"/>
-          <p:cNvSpPr txBox="1"/>
-          <p:nvPr/>
-        </p:nvSpPr>
-        <p:spPr>
-          <a:xfrm>
-            <a:off x="6598768" y="2788920"/>
-            <a:ext cx="2240280" cy="914400"/>
-          </a:xfrm>
-          <a:prstGeom prst="rect">
-            <a:avLst/>
-          </a:prstGeom>
-          <a:noFill/>
-          <a:ln/>
-        </p:spPr>
-        <p:txBody>
-          <a:bodyPr wrap="square" lIns="0" tIns="0" rIns="0" bIns="0" rtlCol="0" anchor="ctr"/>
-          <a:lstStyle/>
-          <a:p>
-            <a:pPr indent="0" marL="0">
-              <a:buNone/>
-            </a:pPr>
-            <a:r>
-              <a:rPr lang="en-US" sz="3000" b="1" dirty="0">
-                <a:solidFill>
-                  <a:schemeClr val="accent3"/>
-                </a:solidFill>
-                <a:latin typeface="+mj-lt" pitchFamily="34" charset="0"/>
-                <a:ea typeface="+mj-lt" pitchFamily="34" charset="-122"/>
-                <a:cs typeface="+mj-lt" pitchFamily="34" charset="-120"/>
-              </a:rPr>
-              <a:t>16 GB</a:t>
-            </a:r>
-            <a:endParaRPr lang="en-US" sz="3000" dirty="0"/>
-          </a:p>
-        </p:txBody>
-      </p:sp>
-      <p:sp>
-        <p:nvSpPr>
-          <p:cNvPr id="14" name="Texto 16 GB"/>
-          <p:cNvSpPr txBox="1"/>
-          <p:nvPr/>
-        </p:nvSpPr>
-        <p:spPr>
-          <a:xfrm>
-            <a:off x="8930488" y="2788920"/>
-            <a:ext cx="2346808" cy="914400"/>
-          </a:xfrm>
-          <a:prstGeom prst="rect">
-            <a:avLst/>
-          </a:prstGeom>
-          <a:noFill/>
-          <a:ln/>
-        </p:spPr>
-        <p:txBody>
-          <a:bodyPr wrap="square" lIns="0" tIns="0" rIns="0" bIns="0" rtlCol="0" anchor="ctr"/>
-          <a:lstStyle/>
-          <a:p>
-            <a:pPr indent="0" marL="0">
-              <a:buNone/>
-            </a:pPr>
-            <a:r>
-              <a:rPr lang="en-US" sz="1600" dirty="0">
-                <a:solidFill>
-                  <a:schemeClr val="bg2"/>
+              <a:rPr lang="en-US" sz="1200" dirty="0">
+                <a:solidFill>
+                  <a:schemeClr val="accent5"/>
                 </a:solidFill>
                 <a:latin typeface="+mn-lt" pitchFamily="34" charset="0"/>
                 <a:ea typeface="+mn-lt" pitchFamily="34" charset="-122"/>
                 <a:cs typeface="+mn-lt" pitchFamily="34" charset="-120"/>
               </a:rPr>
-              <a:t>Fotogramas sueltos del vídeo: se pueden borrar si basta con el MP4.</a:t>
-            </a:r>
-            <a:endParaRPr lang="en-US" sz="1600" dirty="0"/>
-          </a:p>
-        </p:txBody>
-      </p:sp>
-      <p:sp>
-        <p:nvSpPr>
-          <p:cNvPr id="15" name="Cifra 20–30 MB"/>
-          <p:cNvSpPr txBox="1"/>
-          <p:nvPr/>
-        </p:nvSpPr>
-        <p:spPr>
-          <a:xfrm>
-            <a:off x="6598768" y="3931920"/>
-            <a:ext cx="2240280" cy="914400"/>
-          </a:xfrm>
-          <a:prstGeom prst="rect">
-            <a:avLst/>
-          </a:prstGeom>
-          <a:noFill/>
-          <a:ln/>
-        </p:spPr>
-        <p:txBody>
-          <a:bodyPr wrap="square" lIns="0" tIns="0" rIns="0" bIns="0" rtlCol="0" anchor="ctr"/>
-          <a:lstStyle/>
-          <a:p>
-            <a:pPr indent="0" marL="0">
-              <a:buNone/>
-            </a:pPr>
-            <a:r>
-              <a:rPr lang="en-US" sz="3000" b="1" dirty="0">
-                <a:solidFill>
-                  <a:schemeClr val="accent3"/>
-                </a:solidFill>
-                <a:latin typeface="+mj-lt" pitchFamily="34" charset="0"/>
-                <a:ea typeface="+mj-lt" pitchFamily="34" charset="-122"/>
-                <a:cs typeface="+mj-lt" pitchFamily="34" charset="-120"/>
-              </a:rPr>
-              <a:t>20–30 MB</a:t>
-            </a:r>
-            <a:endParaRPr lang="en-US" sz="3000" dirty="0"/>
-          </a:p>
-        </p:txBody>
-      </p:sp>
-      <p:sp>
-        <p:nvSpPr>
-          <p:cNvPr id="16" name="Texto 20–30 MB"/>
-          <p:cNvSpPr txBox="1"/>
-          <p:nvPr/>
-        </p:nvSpPr>
-        <p:spPr>
-          <a:xfrm>
-            <a:off x="8930488" y="3931920"/>
-            <a:ext cx="2346808" cy="914400"/>
-          </a:xfrm>
-          <a:prstGeom prst="rect">
-            <a:avLst/>
-          </a:prstGeom>
-          <a:noFill/>
-          <a:ln/>
-        </p:spPr>
-        <p:txBody>
-          <a:bodyPr wrap="square" lIns="0" tIns="0" rIns="0" bIns="0" rtlCol="0" anchor="ctr"/>
-          <a:lstStyle/>
-          <a:p>
-            <a:pPr indent="0" marL="0">
-              <a:buNone/>
-            </a:pPr>
-            <a:r>
-              <a:rPr lang="en-US" sz="1600" dirty="0">
-                <a:solidFill>
-                  <a:schemeClr val="bg2"/>
-                </a:solidFill>
-                <a:latin typeface="+mn-lt" pitchFamily="34" charset="0"/>
-                <a:ea typeface="+mn-lt" pitchFamily="34" charset="-122"/>
-                <a:cs typeface="+mn-lt" pitchFamily="34" charset="-120"/>
-              </a:rPr>
-              <a:t>Al quitar la imagen de referencia del archivo de Blender.</a:t>
-            </a:r>
-            <a:endParaRPr lang="en-US" sz="1600" dirty="0"/>
-          </a:p>
-        </p:txBody>
-      </p:sp>
-      <p:sp>
-        <p:nvSpPr>
-          <p:cNvPr id="17" name="Ficha técnica"/>
-          <p:cNvSpPr txBox="1"/>
-          <p:nvPr/>
-        </p:nvSpPr>
-        <p:spPr>
-          <a:xfrm>
-            <a:off x="548640" y="5623560"/>
-            <a:ext cx="11094415" cy="320040"/>
-          </a:xfrm>
-          <a:prstGeom prst="rect">
-            <a:avLst/>
-          </a:prstGeom>
-          <a:noFill/>
-          <a:ln/>
-        </p:spPr>
-        <p:txBody>
-          <a:bodyPr wrap="square" lIns="0" tIns="0" rIns="0" bIns="0" rtlCol="0" anchor="t"/>
-          <a:lstStyle/>
-          <a:p>
-            <a:pPr indent="0" marL="0">
-              <a:buNone/>
-            </a:pPr>
-            <a:r>
-              <a:rPr lang="en-US" sz="1400" dirty="0">
-                <a:solidFill>
-                  <a:schemeClr val="accent5"/>
-                </a:solidFill>
-                <a:latin typeface="+mn-lt" pitchFamily="34" charset="0"/>
-                <a:ea typeface="+mn-lt" pitchFamily="34" charset="-122"/>
-                <a:cs typeface="+mn-lt" pitchFamily="34" charset="-120"/>
-              </a:rPr>
-              <a:t>Proyecto set_virtual · octubre de 2026 · Blender 5.2, Cycles y EEVEE en una RTX 5090.</a:t>
-            </a:r>
-            <a:endParaRPr lang="en-US" sz="1400" dirty="0"/>
+              <a:t>Desde la mesa principal: pantalla del estadio, escalera, mosaico LED y zona de entrevistas.</a:t>
+            </a:r>
+            <a:endParaRPr lang="en-US" sz="1200" dirty="0"/>
           </a:p>
         </p:txBody>
       </p:sp>

</xml_diff>